<commit_message>
Per-slide speaker beats, bare-beat demo scripts, uv for the Python track
- Reveal sequences carry only the new beat per slide across all six decks;
  build.py splits Notes on a `~` line; hand decks patched in place
- Demo What-to-Watch notes are runnable checklists: files, flags,
  before/after, commands, cut order
- Python: root pyproject.toml + uv.lock, uv run main.py everywhere,
  per-feature requirements.txt removed, SETUP and walkthroughs updated
- Runsheet commands synced; soak record removed at J's request

Co-Authored-By: Claude Fable 5.1 <noreply@anthropic.com>
</commit_message>
<xml_diff>
--- a/docs/slides/pptx/M1-understanding.pptx
+++ b/docs/slides/pptx/M1-understanding.pptx
@@ -5,7 +5,7 @@
     <p:sldMasterId id="2147483660" r:id="rId1"/>
   </p:sldMasterIdLst>
   <p:notesMasterIdLst>
-    <p:notesMasterId r:id="rId34"/>
+    <p:notesMasterId r:id="rId37"/>
   </p:notesMasterIdLst>
   <p:sldIdLst>
     <p:sldId id="576" r:id="rId2"/>
@@ -13,53 +13,53 @@
     <p:sldId id="608" r:id="rId4"/>
     <p:sldId id="609" r:id="rId5"/>
     <p:sldId id="580" r:id="rId6"/>
-    <p:sldId id="610" r:id="rId48"/>
-    <p:sldId id="581" r:id="rId7"/>
-    <p:sldId id="582" r:id="rId8"/>
-    <p:sldId id="583" r:id="rId9"/>
-    <p:sldId id="584" r:id="rId10"/>
-    <p:sldId id="585" r:id="rId11"/>
-    <p:sldId id="586" r:id="rId12"/>
-    <p:sldId id="611" r:id="rId49"/>
-    <p:sldId id="587" r:id="rId13"/>
-    <p:sldId id="588" r:id="rId14"/>
-    <p:sldId id="589" r:id="rId15"/>
-    <p:sldId id="590" r:id="rId16"/>
-    <p:sldId id="591" r:id="rId17"/>
-    <p:sldId id="592" r:id="rId18"/>
-    <p:sldId id="593" r:id="rId19"/>
-    <p:sldId id="594" r:id="rId20"/>
-    <p:sldId id="595" r:id="rId21"/>
-    <p:sldId id="596" r:id="rId22"/>
-    <p:sldId id="597" r:id="rId23"/>
-    <p:sldId id="598" r:id="rId24"/>
-    <p:sldId id="599" r:id="rId25"/>
-    <p:sldId id="600" r:id="rId26"/>
-    <p:sldId id="612" r:id="rId50"/>
-    <p:sldId id="601" r:id="rId27"/>
-    <p:sldId id="602" r:id="rId28"/>
-    <p:sldId id="603" r:id="rId29"/>
-    <p:sldId id="604" r:id="rId30"/>
-    <p:sldId id="605" r:id="rId31"/>
-    <p:sldId id="606" r:id="rId32"/>
-    <p:sldId id="607" r:id="rId33"/>
+    <p:sldId id="610" r:id="rId7"/>
+    <p:sldId id="581" r:id="rId8"/>
+    <p:sldId id="582" r:id="rId9"/>
+    <p:sldId id="583" r:id="rId10"/>
+    <p:sldId id="584" r:id="rId11"/>
+    <p:sldId id="613" r:id="rId12"/>
+    <p:sldId id="586" r:id="rId13"/>
+    <p:sldId id="611" r:id="rId14"/>
+    <p:sldId id="587" r:id="rId15"/>
+    <p:sldId id="588" r:id="rId16"/>
+    <p:sldId id="589" r:id="rId17"/>
+    <p:sldId id="590" r:id="rId18"/>
+    <p:sldId id="591" r:id="rId19"/>
+    <p:sldId id="592" r:id="rId20"/>
+    <p:sldId id="593" r:id="rId21"/>
+    <p:sldId id="594" r:id="rId22"/>
+    <p:sldId id="595" r:id="rId23"/>
+    <p:sldId id="596" r:id="rId24"/>
+    <p:sldId id="597" r:id="rId25"/>
+    <p:sldId id="598" r:id="rId26"/>
+    <p:sldId id="599" r:id="rId27"/>
+    <p:sldId id="600" r:id="rId28"/>
+    <p:sldId id="612" r:id="rId29"/>
+    <p:sldId id="601" r:id="rId30"/>
+    <p:sldId id="602" r:id="rId31"/>
+    <p:sldId id="603" r:id="rId32"/>
+    <p:sldId id="604" r:id="rId33"/>
+    <p:sldId id="605" r:id="rId34"/>
+    <p:sldId id="606" r:id="rId35"/>
+    <p:sldId id="607" r:id="rId36"/>
   </p:sldIdLst>
   <p:sldSz cx="12192000" cy="6858000"/>
   <p:notesSz cx="6858000" cy="9144000"/>
   <p:embeddedFontLst>
     <p:embeddedFont>
       <p:font typeface="Consolas" panose="020B0609020204030204" pitchFamily="49" charset="0"/>
-      <p:regular r:id="rId35"/>
-      <p:bold r:id="rId36"/>
-      <p:italic r:id="rId37"/>
-      <p:boldItalic r:id="rId38"/>
+      <p:regular r:id="rId38"/>
+      <p:bold r:id="rId39"/>
+      <p:italic r:id="rId40"/>
+      <p:boldItalic r:id="rId41"/>
     </p:embeddedFont>
     <p:embeddedFont>
       <p:font typeface="Segoe UI" panose="020B0502040204020203" pitchFamily="34" charset="0"/>
-      <p:regular r:id="rId39"/>
-      <p:bold r:id="rId40"/>
-      <p:italic r:id="rId41"/>
-      <p:boldItalic r:id="rId42"/>
+      <p:regular r:id="rId42"/>
+      <p:bold r:id="rId43"/>
+      <p:italic r:id="rId44"/>
+      <p:boldItalic r:id="rId45"/>
     </p:embeddedFont>
   </p:embeddedFontLst>
   <p:defaultTextStyle>
@@ -170,23 +170,24 @@
   <pc:docChgLst>
     <pc:chgData name="J. Tower" userId="9d06de10716639e5" providerId="LiveId" clId="{F8931099-75CA-5660-A155-55881DF68D84}"/>
     <pc:docChg chg="undo redo custSel addSld delSld modSld sldOrd modSection">
-      <pc:chgData name="J. Tower" userId="9d06de10716639e5" providerId="LiveId" clId="{F8931099-75CA-5660-A155-55881DF68D84}" dt="2026-09-01T19:27:00.215" v="1077" actId="20577"/>
+      <pc:chgData name="J. Tower" userId="9d06de10716639e5" providerId="LiveId" clId="{F8931099-75CA-5660-A155-55881DF68D84}" dt="2026-09-03T19:14:50.590" v="1091" actId="20577"/>
       <pc:docMkLst>
         <pc:docMk/>
       </pc:docMkLst>
-      <pc:sldChg chg="del">
-        <pc:chgData name="J. Tower" userId="9d06de10716639e5" providerId="LiveId" clId="{F8931099-75CA-5660-A155-55881DF68D84}" dt="2026-09-01T19:23:51.287" v="998" actId="2696"/>
+      <pc:sldChg chg="modSp mod">
+        <pc:chgData name="J. Tower" userId="9d06de10716639e5" providerId="LiveId" clId="{F8931099-75CA-5660-A155-55881DF68D84}" dt="2026-09-03T19:08:53.270" v="1086" actId="27636"/>
         <pc:sldMkLst>
           <pc:docMk/>
-          <pc:sldMk cId="0" sldId="577"/>
+          <pc:sldMk cId="0" sldId="576"/>
         </pc:sldMkLst>
-      </pc:sldChg>
-      <pc:sldChg chg="del">
-        <pc:chgData name="J. Tower" userId="9d06de10716639e5" providerId="LiveId" clId="{F8931099-75CA-5660-A155-55881DF68D84}" dt="2026-09-01T19:23:51.294" v="999" actId="2696"/>
-        <pc:sldMkLst>
-          <pc:docMk/>
-          <pc:sldMk cId="0" sldId="578"/>
-        </pc:sldMkLst>
+        <pc:spChg chg="mod">
+          <ac:chgData name="J. Tower" userId="9d06de10716639e5" providerId="LiveId" clId="{F8931099-75CA-5660-A155-55881DF68D84}" dt="2026-09-03T19:08:53.270" v="1086" actId="27636"/>
+          <ac:spMkLst>
+            <pc:docMk/>
+            <pc:sldMk cId="0" sldId="576"/>
+            <ac:spMk id="3" creationId="{00000000-0000-0000-0000-000000000000}"/>
+          </ac:spMkLst>
+        </pc:spChg>
       </pc:sldChg>
       <pc:sldChg chg="delSp modSp mod">
         <pc:chgData name="J. Tower" userId="9d06de10716639e5" providerId="LiveId" clId="{F8931099-75CA-5660-A155-55881DF68D84}" dt="2026-09-01T19:23:57.043" v="1004" actId="478"/>
@@ -210,22 +211,6 @@
             <ac:spMk id="4" creationId="{00000000-0000-0000-0000-000000000000}"/>
           </ac:spMkLst>
         </pc:spChg>
-        <pc:spChg chg="del mod">
-          <ac:chgData name="J. Tower" userId="9d06de10716639e5" providerId="LiveId" clId="{F8931099-75CA-5660-A155-55881DF68D84}" dt="2026-09-01T19:23:57.043" v="1004" actId="478"/>
-          <ac:spMkLst>
-            <pc:docMk/>
-            <pc:sldMk cId="0" sldId="579"/>
-            <ac:spMk id="6" creationId="{00000000-0000-0000-0000-000000000000}"/>
-          </ac:spMkLst>
-        </pc:spChg>
-        <pc:spChg chg="del mod">
-          <ac:chgData name="J. Tower" userId="9d06de10716639e5" providerId="LiveId" clId="{F8931099-75CA-5660-A155-55881DF68D84}" dt="2026-09-01T19:23:57.043" v="1004" actId="478"/>
-          <ac:spMkLst>
-            <pc:docMk/>
-            <pc:sldMk cId="0" sldId="579"/>
-            <ac:spMk id="8" creationId="{00000000-0000-0000-0000-000000000000}"/>
-          </ac:spMkLst>
-        </pc:spChg>
         <pc:picChg chg="mod">
           <ac:chgData name="J. Tower" userId="9d06de10716639e5" providerId="LiveId" clId="{F8931099-75CA-5660-A155-55881DF68D84}" dt="2026-09-01T19:23:40.416" v="994" actId="1076"/>
           <ac:picMkLst>
@@ -234,42 +219,80 @@
             <ac:picMk id="3" creationId="{00000000-0000-0000-0000-000000000000}"/>
           </ac:picMkLst>
         </pc:picChg>
-        <pc:picChg chg="del mod">
-          <ac:chgData name="J. Tower" userId="9d06de10716639e5" providerId="LiveId" clId="{F8931099-75CA-5660-A155-55881DF68D84}" dt="2026-09-01T19:23:57.043" v="1004" actId="478"/>
-          <ac:picMkLst>
-            <pc:docMk/>
-            <pc:sldMk cId="0" sldId="579"/>
-            <ac:picMk id="5" creationId="{00000000-0000-0000-0000-000000000000}"/>
-          </ac:picMkLst>
-        </pc:picChg>
-        <pc:picChg chg="del mod">
-          <ac:chgData name="J. Tower" userId="9d06de10716639e5" providerId="LiveId" clId="{F8931099-75CA-5660-A155-55881DF68D84}" dt="2026-09-01T19:23:57.043" v="1004" actId="478"/>
-          <ac:picMkLst>
-            <pc:docMk/>
-            <pc:sldMk cId="0" sldId="579"/>
-            <ac:picMk id="7" creationId="{00000000-0000-0000-0000-000000000000}"/>
-          </ac:picMkLst>
-        </pc:picChg>
-        <pc:picChg chg="del">
-          <ac:chgData name="J. Tower" userId="9d06de10716639e5" providerId="LiveId" clId="{F8931099-75CA-5660-A155-55881DF68D84}" dt="2026-09-01T19:23:57.043" v="1004" actId="478"/>
-          <ac:picMkLst>
-            <pc:docMk/>
-            <pc:sldMk cId="0" sldId="579"/>
-            <ac:picMk id="9" creationId="{00000000-0000-0000-0000-000000000000}"/>
-          </ac:picMkLst>
-        </pc:picChg>
       </pc:sldChg>
       <pc:sldChg chg="modSp mod">
-        <pc:chgData name="J. Tower" userId="9d06de10716639e5" providerId="LiveId" clId="{F8931099-75CA-5660-A155-55881DF68D84}" dt="2026-09-01T19:24:24.221" v="1007" actId="20577"/>
+        <pc:chgData name="J. Tower" userId="9d06de10716639e5" providerId="LiveId" clId="{F8931099-75CA-5660-A155-55881DF68D84}" dt="2026-09-03T19:08:53.273" v="1087" actId="27636"/>
+        <pc:sldMkLst>
+          <pc:docMk/>
+          <pc:sldMk cId="0" sldId="580"/>
+        </pc:sldMkLst>
+        <pc:spChg chg="mod">
+          <ac:chgData name="J. Tower" userId="9d06de10716639e5" providerId="LiveId" clId="{F8931099-75CA-5660-A155-55881DF68D84}" dt="2026-09-03T19:08:53.273" v="1087" actId="27636"/>
+          <ac:spMkLst>
+            <pc:docMk/>
+            <pc:sldMk cId="0" sldId="580"/>
+            <ac:spMk id="3" creationId="{00000000-0000-0000-0000-000000000000}"/>
+          </ac:spMkLst>
+        </pc:spChg>
+      </pc:sldChg>
+      <pc:sldChg chg="delSp modSp del mod">
+        <pc:chgData name="J. Tower" userId="9d06de10716639e5" providerId="LiveId" clId="{F8931099-75CA-5660-A155-55881DF68D84}" dt="2026-09-03T19:09:00.344" v="1090" actId="2696"/>
         <pc:sldMkLst>
           <pc:docMk/>
           <pc:sldMk cId="0" sldId="585"/>
         </pc:sldMkLst>
         <pc:spChg chg="mod">
-          <ac:chgData name="J. Tower" userId="9d06de10716639e5" providerId="LiveId" clId="{F8931099-75CA-5660-A155-55881DF68D84}" dt="2026-09-01T19:24:24.221" v="1007" actId="20577"/>
+          <ac:chgData name="J. Tower" userId="9d06de10716639e5" providerId="LiveId" clId="{F8931099-75CA-5660-A155-55881DF68D84}" dt="2026-09-03T19:08:49.628" v="1080" actId="21"/>
           <ac:spMkLst>
             <pc:docMk/>
             <pc:sldMk cId="0" sldId="585"/>
+            <ac:spMk id="3" creationId="{00000000-0000-0000-0000-000000000000}"/>
+          </ac:spMkLst>
+        </pc:spChg>
+        <pc:spChg chg="del">
+          <ac:chgData name="J. Tower" userId="9d06de10716639e5" providerId="LiveId" clId="{F8931099-75CA-5660-A155-55881DF68D84}" dt="2026-09-03T19:08:57.937" v="1088" actId="21"/>
+          <ac:spMkLst>
+            <pc:docMk/>
+            <pc:sldMk cId="0" sldId="585"/>
+            <ac:spMk id="4" creationId="{00000000-0000-0000-0000-000000000000}"/>
+          </ac:spMkLst>
+        </pc:spChg>
+        <pc:spChg chg="del">
+          <ac:chgData name="J. Tower" userId="9d06de10716639e5" providerId="LiveId" clId="{F8931099-75CA-5660-A155-55881DF68D84}" dt="2026-09-03T19:08:57.937" v="1088" actId="21"/>
+          <ac:spMkLst>
+            <pc:docMk/>
+            <pc:sldMk cId="0" sldId="585"/>
+            <ac:spMk id="5" creationId="{00000000-0000-0000-0000-000000000000}"/>
+          </ac:spMkLst>
+        </pc:spChg>
+        <pc:spChg chg="del">
+          <ac:chgData name="J. Tower" userId="9d06de10716639e5" providerId="LiveId" clId="{F8931099-75CA-5660-A155-55881DF68D84}" dt="2026-09-03T19:08:57.937" v="1088" actId="21"/>
+          <ac:spMkLst>
+            <pc:docMk/>
+            <pc:sldMk cId="0" sldId="585"/>
+            <ac:spMk id="6" creationId="{00000000-0000-0000-0000-000000000000}"/>
+          </ac:spMkLst>
+        </pc:spChg>
+        <pc:spChg chg="del">
+          <ac:chgData name="J. Tower" userId="9d06de10716639e5" providerId="LiveId" clId="{F8931099-75CA-5660-A155-55881DF68D84}" dt="2026-09-03T19:08:57.937" v="1088" actId="21"/>
+          <ac:spMkLst>
+            <pc:docMk/>
+            <pc:sldMk cId="0" sldId="585"/>
+            <ac:spMk id="7" creationId="{00000000-0000-0000-0000-000000000000}"/>
+          </ac:spMkLst>
+        </pc:spChg>
+      </pc:sldChg>
+      <pc:sldChg chg="modSp mod">
+        <pc:chgData name="J. Tower" userId="9d06de10716639e5" providerId="LiveId" clId="{F8931099-75CA-5660-A155-55881DF68D84}" dt="2026-09-03T19:08:53.249" v="1084" actId="27636"/>
+        <pc:sldMkLst>
+          <pc:docMk/>
+          <pc:sldMk cId="0" sldId="586"/>
+        </pc:sldMkLst>
+        <pc:spChg chg="mod">
+          <ac:chgData name="J. Tower" userId="9d06de10716639e5" providerId="LiveId" clId="{F8931099-75CA-5660-A155-55881DF68D84}" dt="2026-09-03T19:08:53.249" v="1084" actId="27636"/>
+          <ac:spMkLst>
+            <pc:docMk/>
+            <pc:sldMk cId="0" sldId="586"/>
             <ac:spMk id="3" creationId="{00000000-0000-0000-0000-000000000000}"/>
           </ac:spMkLst>
         </pc:spChg>
@@ -359,6 +382,21 @@
         </pc:grpChg>
       </pc:sldChg>
       <pc:sldChg chg="modSp mod">
+        <pc:chgData name="J. Tower" userId="9d06de10716639e5" providerId="LiveId" clId="{F8931099-75CA-5660-A155-55881DF68D84}" dt="2026-09-03T19:08:53.260" v="1085" actId="27636"/>
+        <pc:sldMkLst>
+          <pc:docMk/>
+          <pc:sldMk cId="0" sldId="600"/>
+        </pc:sldMkLst>
+        <pc:spChg chg="mod">
+          <ac:chgData name="J. Tower" userId="9d06de10716639e5" providerId="LiveId" clId="{F8931099-75CA-5660-A155-55881DF68D84}" dt="2026-09-03T19:08:53.260" v="1085" actId="27636"/>
+          <ac:spMkLst>
+            <pc:docMk/>
+            <pc:sldMk cId="0" sldId="600"/>
+            <ac:spMk id="3" creationId="{00000000-0000-0000-0000-000000000000}"/>
+          </ac:spMkLst>
+        </pc:spChg>
+      </pc:sldChg>
+      <pc:sldChg chg="modSp mod">
         <pc:chgData name="J. Tower" userId="9d06de10716639e5" providerId="LiveId" clId="{F8931099-75CA-5660-A155-55881DF68D84}" dt="2026-09-01T19:25:35.687" v="1033" actId="20577"/>
         <pc:sldMkLst>
           <pc:docMk/>
@@ -409,30 +447,6 @@
           <pc:docMk/>
           <pc:sldMk cId="2827037887" sldId="608"/>
         </pc:sldMkLst>
-        <pc:spChg chg="add del">
-          <ac:chgData name="J. Tower" userId="9d06de10716639e5" providerId="LiveId" clId="{F8931099-75CA-5660-A155-55881DF68D84}" dt="2026-09-01T19:24:37.019" v="1009" actId="478"/>
-          <ac:spMkLst>
-            <pc:docMk/>
-            <pc:sldMk cId="2827037887" sldId="608"/>
-            <ac:spMk id="8" creationId="{98A7B041-8925-5027-3FDF-98C905535506}"/>
-          </ac:spMkLst>
-        </pc:spChg>
-        <pc:picChg chg="add del">
-          <ac:chgData name="J. Tower" userId="9d06de10716639e5" providerId="LiveId" clId="{F8931099-75CA-5660-A155-55881DF68D84}" dt="2026-09-01T19:24:37.019" v="1009" actId="478"/>
-          <ac:picMkLst>
-            <pc:docMk/>
-            <pc:sldMk cId="2827037887" sldId="608"/>
-            <ac:picMk id="7" creationId="{B5559A96-24DD-C547-2558-2EDE80D64158}"/>
-          </ac:picMkLst>
-        </pc:picChg>
-        <pc:picChg chg="add del">
-          <ac:chgData name="J. Tower" userId="9d06de10716639e5" providerId="LiveId" clId="{F8931099-75CA-5660-A155-55881DF68D84}" dt="2026-09-01T19:24:37.019" v="1009" actId="478"/>
-          <ac:picMkLst>
-            <pc:docMk/>
-            <pc:sldMk cId="2827037887" sldId="608"/>
-            <ac:picMk id="9" creationId="{48C8BFB8-567E-4173-B470-6A689F056441}"/>
-          </ac:picMkLst>
-        </pc:picChg>
       </pc:sldChg>
       <pc:sldChg chg="add">
         <pc:chgData name="J. Tower" userId="9d06de10716639e5" providerId="LiveId" clId="{F8931099-75CA-5660-A155-55881DF68D84}" dt="2026-09-01T19:23:52.899" v="1001" actId="2890"/>
@@ -440,6 +454,83 @@
           <pc:docMk/>
           <pc:sldMk cId="640487153" sldId="609"/>
         </pc:sldMkLst>
+      </pc:sldChg>
+      <pc:sldChg chg="modSp mod">
+        <pc:chgData name="J. Tower" userId="9d06de10716639e5" providerId="LiveId" clId="{F8931099-75CA-5660-A155-55881DF68D84}" dt="2026-09-03T18:41:29.167" v="1078" actId="20577"/>
+        <pc:sldMkLst>
+          <pc:docMk/>
+          <pc:sldMk cId="0" sldId="610"/>
+        </pc:sldMkLst>
+        <pc:spChg chg="mod">
+          <ac:chgData name="J. Tower" userId="9d06de10716639e5" providerId="LiveId" clId="{F8931099-75CA-5660-A155-55881DF68D84}" dt="2026-09-03T18:41:29.167" v="1078" actId="20577"/>
+          <ac:spMkLst>
+            <pc:docMk/>
+            <pc:sldMk cId="0" sldId="610"/>
+            <ac:spMk id="3" creationId="{00000000-0000-0000-0000-000000000000}"/>
+          </ac:spMkLst>
+        </pc:spChg>
+      </pc:sldChg>
+      <pc:sldChg chg="modSp mod">
+        <pc:chgData name="J. Tower" userId="9d06de10716639e5" providerId="LiveId" clId="{F8931099-75CA-5660-A155-55881DF68D84}" dt="2026-09-03T19:14:50.590" v="1091" actId="20577"/>
+        <pc:sldMkLst>
+          <pc:docMk/>
+          <pc:sldMk cId="0" sldId="611"/>
+        </pc:sldMkLst>
+        <pc:spChg chg="mod">
+          <ac:chgData name="J. Tower" userId="9d06de10716639e5" providerId="LiveId" clId="{F8931099-75CA-5660-A155-55881DF68D84}" dt="2026-09-03T19:14:50.590" v="1091" actId="20577"/>
+          <ac:spMkLst>
+            <pc:docMk/>
+            <pc:sldMk cId="0" sldId="611"/>
+            <ac:spMk id="3" creationId="{00000000-0000-0000-0000-000000000000}"/>
+          </ac:spMkLst>
+        </pc:spChg>
+      </pc:sldChg>
+      <pc:sldChg chg="addSp modSp add mod">
+        <pc:chgData name="J. Tower" userId="9d06de10716639e5" providerId="LiveId" clId="{F8931099-75CA-5660-A155-55881DF68D84}" dt="2026-09-03T19:08:58.611" v="1089"/>
+        <pc:sldMkLst>
+          <pc:docMk/>
+          <pc:sldMk cId="4155427989" sldId="613"/>
+        </pc:sldMkLst>
+        <pc:spChg chg="mod">
+          <ac:chgData name="J. Tower" userId="9d06de10716639e5" providerId="LiveId" clId="{F8931099-75CA-5660-A155-55881DF68D84}" dt="2026-09-03T19:08:53.230" v="1083"/>
+          <ac:spMkLst>
+            <pc:docMk/>
+            <pc:sldMk cId="4155427989" sldId="613"/>
+            <ac:spMk id="3" creationId="{53AA7B6A-70F0-B6ED-7F8B-CFDD9B0C5D16}"/>
+          </ac:spMkLst>
+        </pc:spChg>
+        <pc:spChg chg="add mod">
+          <ac:chgData name="J. Tower" userId="9d06de10716639e5" providerId="LiveId" clId="{F8931099-75CA-5660-A155-55881DF68D84}" dt="2026-09-03T19:08:58.611" v="1089"/>
+          <ac:spMkLst>
+            <pc:docMk/>
+            <pc:sldMk cId="4155427989" sldId="613"/>
+            <ac:spMk id="4" creationId="{B1E8BDC2-EDF4-3F70-F39F-5D43BC13C20A}"/>
+          </ac:spMkLst>
+        </pc:spChg>
+        <pc:spChg chg="add mod">
+          <ac:chgData name="J. Tower" userId="9d06de10716639e5" providerId="LiveId" clId="{F8931099-75CA-5660-A155-55881DF68D84}" dt="2026-09-03T19:08:58.611" v="1089"/>
+          <ac:spMkLst>
+            <pc:docMk/>
+            <pc:sldMk cId="4155427989" sldId="613"/>
+            <ac:spMk id="5" creationId="{CAF20ED4-4633-3742-5916-E3B2624E2928}"/>
+          </ac:spMkLst>
+        </pc:spChg>
+        <pc:spChg chg="add mod">
+          <ac:chgData name="J. Tower" userId="9d06de10716639e5" providerId="LiveId" clId="{F8931099-75CA-5660-A155-55881DF68D84}" dt="2026-09-03T19:08:58.611" v="1089"/>
+          <ac:spMkLst>
+            <pc:docMk/>
+            <pc:sldMk cId="4155427989" sldId="613"/>
+            <ac:spMk id="6" creationId="{1D0D4B1B-DE8A-C911-7CFB-36A2E19A9B00}"/>
+          </ac:spMkLst>
+        </pc:spChg>
+        <pc:spChg chg="add mod">
+          <ac:chgData name="J. Tower" userId="9d06de10716639e5" providerId="LiveId" clId="{F8931099-75CA-5660-A155-55881DF68D84}" dt="2026-09-03T19:08:58.611" v="1089"/>
+          <ac:spMkLst>
+            <pc:docMk/>
+            <pc:sldMk cId="4155427989" sldId="613"/>
+            <ac:spMk id="7" creationId="{4BA60149-5DC8-C3A6-7EF7-64310D95CDE3}"/>
+          </ac:spMkLst>
+        </pc:spChg>
       </pc:sldChg>
     </pc:docChg>
   </pc:docChgLst>
@@ -528,7 +619,7 @@
           <a:p>
             <a:fld id="{4618B0EE-4D36-4F22-9622-021322CFFE3A}" type="datetimeFigureOut">
               <a:rPr lang="en-US" smtClean="0"/>
-              <a:t>9/1/26</a:t>
+              <a:t>9/3/26</a:t>
             </a:fld>
             <a:endParaRPr lang="en-US"/>
           </a:p>
@@ -870,7 +961,13 @@
   <p:cSld>
     <p:spTree>
       <p:nvGrpSpPr>
-        <p:cNvPr id="1" name=""/>
+        <p:cNvPr id="1" name="">
+          <a:extLst>
+            <a:ext uri="{FF2B5EF4-FFF2-40B4-BE49-F238E27FC236}">
+              <a16:creationId xmlns:a16="http://schemas.microsoft.com/office/drawing/2014/main" id="{87B6AA14-0B22-1FF2-8EE2-38F9AB0400B9}"/>
+            </a:ext>
+          </a:extLst>
+        </p:cNvPr>
         <p:cNvGrpSpPr/>
         <p:nvPr/>
       </p:nvGrpSpPr>
@@ -884,7 +981,13 @@
       </p:grpSpPr>
       <p:sp>
         <p:nvSpPr>
-          <p:cNvPr id="2" name="Slide Image Placeholder 1"/>
+          <p:cNvPr id="2" name="Slide Image Placeholder 1">
+            <a:extLst>
+              <a:ext uri="{FF2B5EF4-FFF2-40B4-BE49-F238E27FC236}">
+                <a16:creationId xmlns:a16="http://schemas.microsoft.com/office/drawing/2014/main" id="{A59D2D40-6F61-708C-A418-80332947701E}"/>
+              </a:ext>
+            </a:extLst>
+          </p:cNvPr>
           <p:cNvSpPr>
             <a:spLocks noGrp="1" noRot="1" noChangeAspect="1"/>
           </p:cNvSpPr>
@@ -896,7 +999,13 @@
       </p:sp>
       <p:sp>
         <p:nvSpPr>
-          <p:cNvPr id="3" name="Notes Placeholder 2"/>
+          <p:cNvPr id="3" name="Notes Placeholder 2">
+            <a:extLst>
+              <a:ext uri="{FF2B5EF4-FFF2-40B4-BE49-F238E27FC236}">
+                <a16:creationId xmlns:a16="http://schemas.microsoft.com/office/drawing/2014/main" id="{FA9C3CD7-0C20-33CD-C4F0-5746E87039A6}"/>
+              </a:ext>
+            </a:extLst>
+          </p:cNvPr>
           <p:cNvSpPr>
             <a:spLocks noGrp="1"/>
           </p:cNvSpPr>
@@ -910,19 +1019,20 @@
           <a:lstStyle/>
           <a:p>
             <a:r>
-              <a:t>The user problem, spoken, 60 seconds: Trailhead wants a "trail stats" panel — which trails, when, how far, what wildlife, what condition. All of it exists as prose across the forty reports, and today a human would re-read and re-type it. So the panel doesn't exist.</a:t>
-            </a:r>
-          </a:p>
-          <a:p>
-            <a:r>
-              <a:t>This one gets the module's one concept slide, because the pipeline — and where it lies to you — is the lesson.</a:t>
-            </a:r>
-          </a:p>
-        </p:txBody>
-      </p:sp>
-      <p:sp>
-        <p:nvSpPr>
-          <p:cNvPr id="4" name="Slide Number Placeholder 3"/>
+              <a:t>The line for your boss; read it. Row 1 of the framework.</a:t>
+            </a:r>
+          </a:p>
+        </p:txBody>
+      </p:sp>
+      <p:sp>
+        <p:nvSpPr>
+          <p:cNvPr id="4" name="Slide Number Placeholder 3">
+            <a:extLst>
+              <a:ext uri="{FF2B5EF4-FFF2-40B4-BE49-F238E27FC236}">
+                <a16:creationId xmlns:a16="http://schemas.microsoft.com/office/drawing/2014/main" id="{38FEB8C3-503B-9049-7658-CCB7B60590CF}"/>
+              </a:ext>
+            </a:extLst>
+          </p:cNvPr>
           <p:cNvSpPr>
             <a:spLocks noGrp="1"/>
           </p:cNvSpPr>
@@ -933,6 +1043,11 @@
         <p:spPr/>
       </p:sp>
     </p:spTree>
+    <p:extLst>
+      <p:ext uri="{BB962C8B-B14F-4D97-AF65-F5344CB8AC3E}">
+        <p14:creationId xmlns:p14="http://schemas.microsoft.com/office/powerpoint/2010/main" val="2190145711"/>
+      </p:ext>
+    </p:extLst>
   </p:cSld>
   <p:clrMapOvr>
     <a:masterClrMapping/>
@@ -985,12 +1100,12 @@
           <a:lstStyle/>
           <a:p>
             <a:r>
-              <a:t>JSON mode guarantees syntax, not truth. A silently stored zero is the bug.</a:t>
-            </a:r>
-          </a:p>
-          <a:p>
-            <a:r>
-              <a:t>The last box is the one people skip. Say plainly that extraction without validation is a data-corruption feature.</a:t>
+              <a:t>The user problem, spoken, 60 seconds: Trailhead wants a "trail stats" panel — which trails, when, how far, what wildlife, what condition. All of it exists as prose across the forty reports, and today a human would re-read and re-type it. So the panel doesn't exist.</a:t>
+            </a:r>
+          </a:p>
+          <a:p>
+            <a:r>
+              <a:t>This one gets the module's one concept slide, because the pipeline — and where it lies to you — is the lesson.</a:t>
             </a:r>
           </a:p>
         </p:txBody>
@@ -1060,12 +1175,7 @@
           <a:lstStyle/>
           <a:p>
             <a:r>
-              <a:t>JSON mode guarantees syntax, not truth. A silently stored zero is the bug.</a:t>
-            </a:r>
-          </a:p>
-          <a:p>
-            <a:r>
-              <a:t>The last box is the one people skip. Say plainly that extraction without validation is a data-corruption feature.</a:t>
+              <a:t>The textbook version: information extraction turns unstructured text into structured data. JSON mode guarantees the shape; it does not guarantee the truth.</a:t>
             </a:r>
           </a:p>
         </p:txBody>
@@ -1135,12 +1245,7 @@
           <a:lstStyle/>
           <a:p>
             <a:r>
-              <a:t>JSON mode guarantees syntax, not truth. A silently stored zero is the bug.</a:t>
-            </a:r>
-          </a:p>
-          <a:p>
-            <a:r>
-              <a:t>The last box is the one people skip. Say plainly that extraction without validation is a data-corruption feature.</a:t>
+              <a:t>The input is prose: the same trip report from 01.</a:t>
             </a:r>
           </a:p>
         </p:txBody>
@@ -1210,12 +1315,7 @@
           <a:lstStyle/>
           <a:p>
             <a:r>
-              <a:t>JSON mode guarantees syntax, not truth. A silently stored zero is the bug.</a:t>
-            </a:r>
-          </a:p>
-          <a:p>
-            <a:r>
-              <a:t>The last box is the one people skip. Say plainly that extraction without validation is a data-corruption feature.</a:t>
+              <a:t>The prompt is the schema in words: fields, types, examples, and "null when absent."</a:t>
             </a:r>
           </a:p>
         </p:txBody>
@@ -1285,12 +1385,7 @@
           <a:lstStyle/>
           <a:p>
             <a:r>
-              <a:t>JSON mode guarantees syntax, not truth. A silently stored zero is the bug.</a:t>
-            </a:r>
-          </a:p>
-          <a:p>
-            <a:r>
-              <a:t>The last box is the one people skip. Say plainly that extraction without validation is a data-corruption feature.</a:t>
+              <a:t>llama3.2 in JSON mode. JSON mode guarantees syntax, not truth.</a:t>
             </a:r>
           </a:p>
         </p:txBody>
@@ -1360,12 +1455,7 @@
           <a:lstStyle/>
           <a:p>
             <a:r>
-              <a:t>JSON mode guarantees syntax, not truth. A silently stored zero is the bug.</a:t>
-            </a:r>
-          </a:p>
-          <a:p>
-            <a:r>
-              <a:t>The last box is the one people skip. Say plainly that extraction without validation is a data-corruption feature.</a:t>
+              <a:t>Parse and validate against the schema. This is the box people skip.</a:t>
             </a:r>
           </a:p>
         </p:txBody>
@@ -1435,12 +1525,7 @@
           <a:lstStyle/>
           <a:p>
             <a:r>
-              <a:t>JSON mode guarantees syntax, not truth. A silently stored zero is the bug.</a:t>
-            </a:r>
-          </a:p>
-          <a:p>
-            <a:r>
-              <a:t>The last box is the one people skip. Say plainly that extraction without validation is a data-corruption feature.</a:t>
+              <a:t>Store, or reject and log. A silently stored zero is the bug.</a:t>
             </a:r>
           </a:p>
         </p:txBody>
@@ -1510,12 +1595,7 @@
           <a:lstStyle/>
           <a:p>
             <a:r>
-              <a:t>JSON mode guarantees syntax, not truth. A silently stored zero is the bug.</a:t>
-            </a:r>
-          </a:p>
-          <a:p>
-            <a:r>
-              <a:t>The last box is the one people skip. Say plainly that extraction without validation is a data-corruption feature.</a:t>
+              <a:t>The model writes JSON; your code decides whether to believe it.</a:t>
             </a:r>
           </a:p>
         </p:txBody>
@@ -1585,96 +1665,7 @@
           <a:lstStyle/>
           <a:p>
             <a:r>
-              <a:t>After the schema fix, something else usually still slips: </a:t>
-            </a:r>
-            <a:r>
-              <a:rPr>
-                <a:latin typeface="Consolas"/>
-              </a:rPr>
-              <a:t>elevation_gain_ft: 0</a:t>
-            </a:r>
-            <a:r>
-              <a:t> where the honest answer is </a:t>
-            </a:r>
-            <a:r>
-              <a:rPr>
-                <a:latin typeface="Consolas"/>
-              </a:rPr>
-              <a:t>null</a:t>
-            </a:r>
-            <a:r>
-              <a:t>, or "early last month" as a date. Zero is the dangerous miss: it is a value, and a pipeline will store it without complaint. Ship the schema plus a rejection rule.</a:t>
-            </a:r>
-          </a:p>
-          <a:p>
-            <a:r>
-              <a:t>Demo script (~10 min; the break-it beat in step 4 is the first cut):</a:t>
-            </a:r>
-          </a:p>
-          <a:p>
-            <a:r>
-              <a:t>1. Show the same messy trip report from feature 01. This time the goal isn't a summary, it's a database row.</a:t>
-            </a:r>
-          </a:p>
-          <a:p>
-            <a:r>
-              <a:t>2. Define a C# record (</a:t>
-            </a:r>
-            <a:r>
-              <a:rPr>
-                <a:latin typeface="Consolas"/>
-              </a:rPr>
-              <a:t>TripFacts</a:t>
-            </a:r>
-            <a:r>
-              <a:t>: trail, park, date, distance, wildlife, conditions) and use Microsoft.Extensions.AI's typed-response support to request it directly. The schema is code.</a:t>
-            </a:r>
-          </a:p>
-          <a:p>
-            <a:r>
-              <a:t>3. Run it: prose in, populated .NET object out, with no parsing step. This is the payoff moment.</a:t>
-            </a:r>
-          </a:p>
-          <a:p>
-            <a:r>
-              <a:t>4. Break it on purpose: run a report that never mentions distance, and watch the model invent </a:t>
-            </a:r>
-            <a:r>
-              <a:rPr>
-                <a:latin typeface="Consolas"/>
-              </a:rPr>
-              <a:t>distance_mi: 5.0</a:t>
-            </a:r>
-            <a:r>
-              <a:t>.</a:t>
-            </a:r>
-          </a:p>
-          <a:p>
-            <a:r>
-              <a:t>5. Fix it in the schema with nullable fields and "null when not stated" descriptions. Re-run: the invented distance usually goes away, and something else usually doesn't. Run it two or three times live so the room sees the variance rather than one lucky result. Then say the quiet part: this is better, and it is not a guarantee. The last mile is a validator that rejects a date like "early last month" and a </a:t>
-            </a:r>
-            <a:r>
-              <a:rPr>
-                <a:latin typeface="Consolas"/>
-              </a:rPr>
-              <a:t>0</a:t>
-            </a:r>
-            <a:r>
-              <a:t> that should have been </a:t>
-            </a:r>
-            <a:r>
-              <a:rPr>
-                <a:latin typeface="Consolas"/>
-              </a:rPr>
-              <a:t>null</a:t>
-            </a:r>
-            <a:r>
-              <a:t>, which is ordinary code your team already knows how to write.</a:t>
-            </a:r>
-          </a:p>
-          <a:p>
-            <a:r>
-              <a:t>6. Zoom out: loop over ten reports and print rows. That's an ingestion pipeline in thirty lines, and the "trail stats" panel is now just a query.</a:t>
+              <a:t>The null rule and the validator are the feature. Say plainly that extraction without validation is a data-corruption feature.</a:t>
             </a:r>
           </a:p>
         </p:txBody>
@@ -1754,12 +1745,7 @@
           </a:p>
           <a:p>
             <a:r>
-              <a:t>The thread to watch all module: asked for something it cannot find, a model supplies something plausible rather than nothing. 01 invents a closure, 02 invents a distance, 03 believes the sarcasm. A better model does not fix it; a tighter instruction, a null-able schema, and checking code do.</a:t>
-            </a:r>
-          </a:p>
-          <a:p>
-            <a:r>
-              <a:t>Set the rhythm expectation out loud: three quick demos with a card for your boss after each, then the room builds for an hour — 01 recommended, 02 and 03 for anyone with time left.</a:t>
+              <a:t>01: forty trip reports become a three-bullet briefing.</a:t>
             </a:r>
           </a:p>
         </p:txBody>
@@ -1829,12 +1815,7 @@
           <a:lstStyle/>
           <a:p>
             <a:r>
-              <a:t>Invoices, resumes, support emails, contracts, legacy records. Row 2.</a:t>
-            </a:r>
-          </a:p>
-          <a:p>
-            <a:r>
-              <a:t>If asked about cost: days to a working pipeline; the real work is schema design and spot-checking accuracy.</a:t>
+              <a:t>A rejected record is a good outcome; it is the pipeline telling you the truth.</a:t>
             </a:r>
           </a:p>
         </p:txBody>
@@ -1904,12 +1885,134 @@
           <a:lstStyle/>
           <a:p>
             <a:r>
-              <a:t>Invoices, resumes, support emails, contracts, legacy records. Row 2.</a:t>
-            </a:r>
-          </a:p>
-          <a:p>
-            <a:r>
-              <a:t>If asked about cost: days to a working pipeline; the real work is schema design and spot-checking accuracy.</a:t>
+              <a:rPr dirty="0"/>
+              <a:t>~10 min · Terminal 2 · </a:t>
+            </a:r>
+            <a:r>
+              <a:rPr dirty="0">
+                <a:latin typeface="Consolas"/>
+              </a:rPr>
+              <a:t>cd modules/M1-understanding/F02-extraction/dotnet</a:t>
+            </a:r>
+          </a:p>
+          <a:p>
+            <a:r>
+              <a:rPr dirty="0"/>
+              <a:t>Files: </a:t>
+            </a:r>
+            <a:r>
+              <a:rPr dirty="0">
+                <a:latin typeface="Consolas"/>
+              </a:rPr>
+              <a:t>tr-0007.md</a:t>
+            </a:r>
+            <a:r>
+              <a:rPr dirty="0"/>
+              <a:t> = full report, every field present · </a:t>
+            </a:r>
+            <a:r>
+              <a:rPr dirty="0">
+                <a:latin typeface="Consolas"/>
+              </a:rPr>
+              <a:t>tr-0011.md</a:t>
+            </a:r>
+            <a:r>
+              <a:rPr dirty="0"/>
+              <a:t> = sparse report, no distance stated (the null test)</a:t>
+            </a:r>
+          </a:p>
+          <a:p>
+            <a:r>
+              <a:rPr dirty="0" err="1"/>
+              <a:t>Args</a:t>
+            </a:r>
+            <a:r>
+              <a:rPr dirty="0"/>
+              <a:t>: a report path; complete with no </a:t>
+            </a:r>
+            <a:r>
+              <a:rPr dirty="0" err="1"/>
+              <a:t>args</a:t>
+            </a:r>
+            <a:r>
+              <a:rPr dirty="0"/>
+              <a:t> runs both</a:t>
+            </a:r>
+          </a:p>
+          <a:p>
+            <a:r>
+              <a:rPr dirty="0"/>
+              <a:t>1. Same kind of report as 01. This time the goal is a database row.</a:t>
+            </a:r>
+          </a:p>
+          <a:p>
+            <a:r>
+              <a:rPr dirty="0"/>
+              <a:t>2. Before: </a:t>
+            </a:r>
+            <a:r>
+              <a:rPr dirty="0">
+                <a:latin typeface="Consolas"/>
+              </a:rPr>
+              <a:t>cd starter &amp;&amp; dotnet run -- ../../data/tr-0007.md</a:t>
+            </a:r>
+            <a:r>
+              <a:rPr dirty="0"/>
+              <a:t>. JSON asked for in the prompt. Fences, preamble, drifting field names.</a:t>
+            </a:r>
+          </a:p>
+          <a:p>
+            <a:r>
+              <a:rPr dirty="0"/>
+              <a:t>3. After: </a:t>
+            </a:r>
+            <a:r>
+              <a:rPr dirty="0">
+                <a:latin typeface="Consolas"/>
+              </a:rPr>
+              <a:t>cd ../complete &amp;&amp; dotnet run -- ../../data/tr-0007.md</a:t>
+            </a:r>
+            <a:r>
+              <a:rPr dirty="0"/>
+              <a:t>. </a:t>
+            </a:r>
+            <a:r>
+              <a:rPr dirty="0" err="1">
+                <a:latin typeface="Consolas"/>
+              </a:rPr>
+              <a:t>TripFacts</a:t>
+            </a:r>
+            <a:r>
+              <a:rPr dirty="0"/>
+              <a:t> record, typed response, no parsing.</a:t>
+            </a:r>
+          </a:p>
+          <a:p>
+            <a:r>
+              <a:rPr dirty="0"/>
+              <a:t>4. </a:t>
+            </a:r>
+            <a:r>
+              <a:rPr dirty="0">
+                <a:latin typeface="Consolas"/>
+              </a:rPr>
+              <a:t>dotnet run -- ../../data/tr-0011.md</a:t>
+            </a:r>
+            <a:r>
+              <a:rPr dirty="0"/>
+              <a:t>, three times. Nulls where there is nothing, and watch what still slips.</a:t>
+            </a:r>
+          </a:p>
+          <a:p>
+            <a:r>
+              <a:rPr dirty="0"/>
+              <a:t>5. Point at the validator: PASS or REJECT. A rejected record is a good outcome.</a:t>
+            </a:r>
+          </a:p>
+          <a:p>
+            <a:r>
+              <a:rPr dirty="0"/>
+              <a:t>Cut: 4's repeats.</a:t>
             </a:r>
           </a:p>
         </p:txBody>
@@ -1979,12 +2082,7 @@
           <a:lstStyle/>
           <a:p>
             <a:r>
-              <a:t>Invoices, resumes, support emails, contracts, legacy records. Row 2.</a:t>
-            </a:r>
-          </a:p>
-          <a:p>
-            <a:r>
-              <a:t>If asked about cost: days to a working pipeline; the real work is schema design and spot-checking accuracy.</a:t>
+              <a:t>Invoices, resumes, support emails, contracts, legacy records.</a:t>
             </a:r>
           </a:p>
         </p:txBody>
@@ -2054,12 +2152,7 @@
           <a:lstStyle/>
           <a:p>
             <a:r>
-              <a:t>The user problem, spoken, 60 seconds: the Cascade 65 backpack has 300 reviews. Are people happy, and what are they mad about? Star ratings lie — "4 stars, but the hip belt broke on day two." The user here is the product team, not the hiker; track the signal weekly and a defect surfaces months before returns spike.</a:t>
-            </a:r>
-          </a:p>
-          <a:p>
-            <a:r>
-              <a:t>No concept slide: this is classification, and the demo IS the lesson — the day's model-selection experiment. phi3 free and local vs gpt-4.1 on Azure, same prompt, and you measure instead of assume.</a:t>
+              <a:t>The line for your boss. Row 2.</a:t>
             </a:r>
           </a:p>
         </p:txBody>
@@ -2129,114 +2222,7 @@
           <a:lstStyle/>
           <a:p>
             <a:r>
-              <a:t>Both halves of the argument hold: ordinary reviews barely need the big model, and the sarcastic slice does, 7/10 vs 10/10, with every disagreement going the frontier model's way. The local stand-in (</a:t>
-            </a:r>
-            <a:r>
-              <a:rPr>
-                <a:latin typeface="Consolas"/>
-              </a:rPr>
-              <a:t>llama3.2</a:t>
-            </a:r>
-            <a:r>
-              <a:t>) came within one review of phi3, so a comparison against the wrong big model would have said the gap barely exists. Side finding worth 20 seconds: reflowing the identical prompt onto one line dropped phi3 to 7/10 and 4/10. Small models are sensitive to formatting.</a:t>
-            </a:r>
-          </a:p>
-          <a:p>
-            <a:r>
-              <a:t>Close with the decision recipe: labeled sample, run both, count disagreements, price the errors. That recipe generalizes to every feature today.</a:t>
-            </a:r>
-          </a:p>
-          <a:p>
-            <a:r>
-              <a:t>Demo script (~10 min; the hard-set diff in step 5 is the heart — cut step 4's Azure easy-run first if behind):</a:t>
-            </a:r>
-          </a:p>
-          <a:p>
-            <a:r>
-              <a:t>1. Show the Cascade 65's reviews and point at a 4-star review with furious text, which is the whole case for reading the text rather than the stars.</a:t>
-            </a:r>
-          </a:p>
-          <a:p>
-            <a:r>
-              <a:t>2. Starter project: one classify method whose prompt returns exactly </a:t>
-            </a:r>
-            <a:r>
-              <a:rPr>
-                <a:latin typeface="Consolas"/>
-              </a:rPr>
-              <a:t>positive | negative | mixed</a:t>
-            </a:r>
-            <a:r>
-              <a:t>. Because of Microsoft.Extensions.AI, the same code runs against both providers, and the swap is one line in DI registration. Say that out loud, since it's the provider-flexibility slide made real.</a:t>
-            </a:r>
-          </a:p>
-          <a:p>
-            <a:r>
-              <a:t>3. Run 20 easy reviews through </a:t>
-            </a:r>
-            <a:r>
-              <a:rPr>
-                <a:latin typeface="Consolas"/>
-              </a:rPr>
-              <a:t>phi3</a:t>
-            </a:r>
-            <a:r>
-              <a:t> locally, where it is fast, free, and correct, and let the small model win the first round.</a:t>
-            </a:r>
-          </a:p>
-          <a:p>
-            <a:r>
-              <a:t>4. Run the same 20 through </a:t>
-            </a:r>
-            <a:r>
-              <a:rPr>
-                <a:latin typeface="Consolas"/>
-              </a:rPr>
-              <a:t>gpt-4.1</a:t>
-            </a:r>
-            <a:r>
-              <a:t> on Foundry and get the same labels on nine of ten (the frontier model also gets the deadpan four-star rave that </a:t>
-            </a:r>
-            <a:r>
-              <a:rPr>
-                <a:latin typeface="Consolas"/>
-              </a:rPr>
-              <a:t>phi3</a:t>
-            </a:r>
-            <a:r>
-              <a:t> calls mixed), which is the first payoff: on ordinary reviews you'd have paid for very little.</a:t>
-            </a:r>
-          </a:p>
-          <a:p>
-            <a:r>
-              <a:t>5. Now the hard set, sarcasm and mixed reviews. Run both and diff the labels on screen. Second payoff: </a:t>
-            </a:r>
-            <a:r>
-              <a:rPr>
-                <a:latin typeface="Consolas"/>
-              </a:rPr>
-              <a:t>phi3</a:t>
-            </a:r>
-            <a:r>
-              <a:t> drops to 7/10 and </a:t>
-            </a:r>
-            <a:r>
-              <a:rPr>
-                <a:latin typeface="Consolas"/>
-              </a:rPr>
-              <a:t>gpt-4.1</a:t>
-            </a:r>
-            <a:r>
-              <a:t> holds at 10/10, and every disagreement is one the frontier model gets right. This is the slice that earns its price, and you know that because you measured it rather than assumed it. Check </a:t>
-            </a:r>
-            <a:r>
-              <a:rPr>
-                <a:latin typeface="Consolas"/>
-              </a:rPr>
-              <a:t>expected-output.md</a:t>
-            </a:r>
-            <a:r>
-              <a:t> for what happened when this was built, and be ready for the room's answer to differ from yours.</a:t>
+              <a:t>Medium. If asked about cost: days to a working pipeline; the real work is schema design and spot-checking accuracy.</a:t>
             </a:r>
           </a:p>
         </p:txBody>
@@ -2306,12 +2292,12 @@
           <a:lstStyle/>
           <a:p>
             <a:r>
-              <a:t>Reviews, NPS verbatims, tickets, mentions, survey answers. Row 3.</a:t>
-            </a:r>
-          </a:p>
-          <a:p>
-            <a:r>
-              <a:t>If asked about cost: days; the classifier is trivial, the diligence is a labeled sample and an error count.</a:t>
+              <a:t>The user problem, spoken, 60 seconds: the Cascade 65 backpack has 300 reviews. Are people happy, and what are they mad about? Star ratings lie — "4 stars, but the hip belt broke on day two." The user here is the product team, not the hiker; track the signal weekly and a defect surfaces months before returns spike.</a:t>
+            </a:r>
+          </a:p>
+          <a:p>
+            <a:r>
+              <a:t>No concept slide: this is classification, and the demo IS the lesson — the day's model-selection experiment. phi3 free and local vs gpt-4.1 on Azure, same prompt, and you measure instead of assume.</a:t>
             </a:r>
           </a:p>
         </p:txBody>
@@ -2381,12 +2367,7 @@
           <a:lstStyle/>
           <a:p>
             <a:r>
-              <a:t>Reviews, NPS verbatims, tickets, mentions, survey answers. Row 3.</a:t>
-            </a:r>
-          </a:p>
-          <a:p>
-            <a:r>
-              <a:t>If asked about cost: days; the classifier is trivial, the diligence is a labeled sample and an error count.</a:t>
+              <a:t>The textbook version: sentiment analysis identifies the emotional polarity of a piece of text. The stars lie; the words mostly don't.</a:t>
             </a:r>
           </a:p>
         </p:txBody>
@@ -2456,12 +2437,134 @@
           <a:lstStyle/>
           <a:p>
             <a:r>
-              <a:t>Reviews, NPS verbatims, tickets, mentions, survey answers. Row 3.</a:t>
-            </a:r>
-          </a:p>
-          <a:p>
-            <a:r>
-              <a:t>If asked about cost: days; the classifier is trivial, the diligence is a labeled sample and an error count.</a:t>
+              <a:t>~10 min · Terminal 1 (Azure) · </a:t>
+            </a:r>
+            <a:r>
+              <a:rPr>
+                <a:latin typeface="Consolas"/>
+              </a:rPr>
+              <a:t>cd modules/M1-understanding/F03-sentiment/dotnet</a:t>
+            </a:r>
+          </a:p>
+          <a:p>
+            <a:r>
+              <a:t>Files: </a:t>
+            </a:r>
+            <a:r>
+              <a:rPr>
+                <a:latin typeface="Consolas"/>
+              </a:rPr>
+              <a:t>easy.jsonl</a:t>
+            </a:r>
+            <a:r>
+              <a:t> = 10 plain reviews · </a:t>
+            </a:r>
+            <a:r>
+              <a:rPr>
+                <a:latin typeface="Consolas"/>
+              </a:rPr>
+              <a:t>hard.jsonl</a:t>
+            </a:r>
+            <a:r>
+              <a:t> = 10 sarcastic or split reviews · </a:t>
+            </a:r>
+            <a:r>
+              <a:rPr>
+                <a:latin typeface="Consolas"/>
+              </a:rPr>
+              <a:t>reference-labels.json</a:t>
+            </a:r>
+            <a:r>
+              <a:t> = the hand labels</a:t>
+            </a:r>
+          </a:p>
+          <a:p>
+            <a:r>
+              <a:t>Flags: </a:t>
+            </a:r>
+            <a:r>
+              <a:rPr>
+                <a:latin typeface="Consolas"/>
+              </a:rPr>
+              <a:t>--easy</a:t>
+            </a:r>
+            <a:r>
+              <a:t> / </a:t>
+            </a:r>
+            <a:r>
+              <a:rPr>
+                <a:latin typeface="Consolas"/>
+              </a:rPr>
+              <a:t>--hard</a:t>
+            </a:r>
+            <a:r>
+              <a:t> = one set; none = both · starter takes a review id (default gr-0007, the sarcastic one)</a:t>
+            </a:r>
+          </a:p>
+          <a:p>
+            <a:r>
+              <a:t>1. Open </a:t>
+            </a:r>
+            <a:r>
+              <a:rPr>
+                <a:latin typeface="Consolas"/>
+              </a:rPr>
+              <a:t>data/hard.jsonl</a:t>
+            </a:r>
+            <a:r>
+              <a:t>. Find a two-star review with glowing text. Stars lie.</a:t>
+            </a:r>
+          </a:p>
+          <a:p>
+            <a:r>
+              <a:t>2. Before: </a:t>
+            </a:r>
+            <a:r>
+              <a:rPr>
+                <a:latin typeface="Consolas"/>
+              </a:rPr>
+              <a:t>cd starter &amp;&amp; dotnet run</a:t>
+            </a:r>
+            <a:r>
+              <a:t>. One method, one label, gr-0007. Show the DI line: the swap is one line.</a:t>
+            </a:r>
+          </a:p>
+          <a:p>
+            <a:r>
+              <a:t>3. After: </a:t>
+            </a:r>
+            <a:r>
+              <a:rPr>
+                <a:latin typeface="Consolas"/>
+              </a:rPr>
+              <a:t>cd ../complete &amp;&amp; dotnet run -- --easy</a:t>
+            </a:r>
+            <a:r>
+              <a:t>. phi3 9/10, gpt-4.1 10/10. Paid for one review.</a:t>
+            </a:r>
+          </a:p>
+          <a:p>
+            <a:r>
+              <a:t>4. </a:t>
+            </a:r>
+            <a:r>
+              <a:rPr>
+                <a:latin typeface="Consolas"/>
+              </a:rPr>
+              <a:t>dotnet run -- --hard</a:t>
+            </a:r>
+            <a:r>
+              <a:t>: phi3 7/10, gpt-4.1 10/10. Diff on screen. Every miss goes the frontier model's way.</a:t>
+            </a:r>
+          </a:p>
+          <a:p>
+            <a:r>
+              <a:t>5. The recipe: labeled sample, run both, count disagreements, price the errors.</a:t>
+            </a:r>
+          </a:p>
+          <a:p>
+            <a:r>
+              <a:t>Cut: 3, go straight to 4.</a:t>
             </a:r>
           </a:p>
         </p:txBody>
@@ -2531,17 +2634,7 @@
           <a:lstStyle/>
           <a:p>
             <a:r>
-              <a:t>Start with 01 regardless of experience: one endpoint, one prompt, two reports; everything else today assumes you've made one model call and seen what comes back. New to this? Budget the full time and do the stretch goal.</a:t>
-            </a:r>
-          </a:p>
-          <a:p>
-            <a:r>
-              <a:t>Pick 03 if your question at work is "which model should we pay for" — its Azure half needs the room key. 02's done-check: the sparse report comes back with nulls and the validator says PASS/REJECT honestly.</a:t>
-            </a:r>
-          </a:p>
-          <a:p>
-            <a:r>
-              <a:t>Finished everything? Help someone near you.</a:t>
+              <a:t>Reviews, NPS verbatims, tickets, mentions, survey answers.</a:t>
             </a:r>
           </a:p>
         </p:txBody>
@@ -2611,12 +2704,7 @@
           <a:lstStyle/>
           <a:p>
             <a:r>
-              <a:t>Ask two people what surprised them.</a:t>
-            </a:r>
-          </a:p>
-          <a:p>
-            <a:r>
-              <a:t>Prompts if quiet: what surfaced the buried bridge, and what invented one? Rows 1–3 of the framework are done. Break, then Module 2.</a:t>
+              <a:t>The line for your boss, and today you measured it. Row 3.</a:t>
             </a:r>
           </a:p>
         </p:txBody>
@@ -2704,22 +2792,7 @@
           <a:lstStyle/>
           <a:p>
             <a:r>
-              <a:t>One model call + one careful instruction; the rhythm is three demos, then your lab hour.</a:t>
-            </a:r>
-          </a:p>
-          <a:p>
-            <a:r>
-              <a:t>Three features, one shape: a single chat call and a carefully written instruction. No vector database, no training, no cloud.</a:t>
-            </a:r>
-          </a:p>
-          <a:p>
-            <a:r>
-              <a:t>The thread to watch all module: asked for something it cannot find, a model supplies something plausible rather than nothing. 01 invents a closure, 02 invents a distance, 03 believes the sarcasm. A better model does not fix it; a tighter instruction, a null-able schema, and checking code do.</a:t>
-            </a:r>
-          </a:p>
-          <a:p>
-            <a:r>
-              <a:t>Set the rhythm expectation out loud: three quick demos with a card for your boss after each, then the room builds for an hour — 01 recommended, 02 and 03 for anyone with time left.</a:t>
+              <a:t>02: the same prose becomes a database row, and your code decides whether to believe it.</a:t>
             </a:r>
           </a:p>
         </p:txBody>
@@ -2756,7 +2829,7 @@
 </file>
 
 <file path=ppt/notesSlides/notesSlide30.xml><?xml version="1.0" encoding="utf-8"?>
-<p:notes xmlns:a="http://schemas.openxmlformats.org/drawingml/2006/main" xmlns:p="http://schemas.openxmlformats.org/presentationml/2006/main" xmlns:r="http://schemas.openxmlformats.org/officeDocument/2006/relationships">
+<p:notes xmlns:a="http://schemas.openxmlformats.org/drawingml/2006/main" xmlns:r="http://schemas.openxmlformats.org/officeDocument/2006/relationships" xmlns:p="http://schemas.openxmlformats.org/presentationml/2006/main">
   <p:cSld>
     <p:spTree>
       <p:nvGrpSpPr>
@@ -2776,7 +2849,7 @@
         <p:nvSpPr>
           <p:cNvPr id="2" name="Slide Image Placeholder 1"/>
           <p:cNvSpPr>
-            <a:spLocks noGrp="1"/>
+            <a:spLocks noGrp="1" noRot="1" noChangeAspect="1"/>
           </p:cNvSpPr>
           <p:nvPr>
             <p:ph type="sldImg" idx="2"/>
@@ -2791,7 +2864,7 @@
             <a:spLocks noGrp="1"/>
           </p:cNvSpPr>
           <p:nvPr>
-            <p:ph type="body" idx="3" sz="quarter"/>
+            <p:ph type="body" sz="quarter" idx="3"/>
           </p:nvPr>
         </p:nvSpPr>
         <p:spPr/>
@@ -2800,7 +2873,7 @@
           <a:lstStyle/>
           <a:p>
             <a:r>
-              <a:t>The textbook version: automatic summarization produces a shorter text that keeps the key information of the source. Read the slide, let it sit a beat, then the problem.</a:t>
+              <a:t>Easy. If asked about cost: days; the classifier is trivial, the diligence is a labeled sample and an error count.</a:t>
             </a:r>
           </a:p>
         </p:txBody>
@@ -2812,7 +2885,7 @@
             <a:spLocks noGrp="1"/>
           </p:cNvSpPr>
           <p:nvPr>
-            <p:ph type="sldNum" idx="5" sz="quarter"/>
+            <p:ph type="sldNum" sz="quarter" idx="5"/>
           </p:nvPr>
         </p:nvSpPr>
         <p:spPr/>
@@ -2826,7 +2899,7 @@
 </file>
 
 <file path=ppt/notesSlides/notesSlide31.xml><?xml version="1.0" encoding="utf-8"?>
-<p:notes xmlns:a="http://schemas.openxmlformats.org/drawingml/2006/main" xmlns:p="http://schemas.openxmlformats.org/presentationml/2006/main" xmlns:r="http://schemas.openxmlformats.org/officeDocument/2006/relationships">
+<p:notes xmlns:a="http://schemas.openxmlformats.org/drawingml/2006/main" xmlns:r="http://schemas.openxmlformats.org/officeDocument/2006/relationships" xmlns:p="http://schemas.openxmlformats.org/presentationml/2006/main">
   <p:cSld>
     <p:spTree>
       <p:nvGrpSpPr>
@@ -2846,7 +2919,7 @@
         <p:nvSpPr>
           <p:cNvPr id="2" name="Slide Image Placeholder 1"/>
           <p:cNvSpPr>
-            <a:spLocks noGrp="1"/>
+            <a:spLocks noGrp="1" noRot="1" noChangeAspect="1"/>
           </p:cNvSpPr>
           <p:nvPr>
             <p:ph type="sldImg" idx="2"/>
@@ -2861,7 +2934,7 @@
             <a:spLocks noGrp="1"/>
           </p:cNvSpPr>
           <p:nvPr>
-            <p:ph type="body" idx="3" sz="quarter"/>
+            <p:ph type="body" sz="quarter" idx="3"/>
           </p:nvPr>
         </p:nvSpPr>
         <p:spPr/>
@@ -2870,7 +2943,17 @@
           <a:lstStyle/>
           <a:p>
             <a:r>
-              <a:t>The textbook version: information extraction turns unstructured text into structured data. JSON mode guarantees the shape; it does not guarantee the truth.</a:t>
+              <a:t>Start with 01 regardless of experience: one endpoint, one prompt, two reports; everything else today assumes you've made one model call and seen what comes back. New to this? Budget the full time and do the stretch goal.</a:t>
+            </a:r>
+          </a:p>
+          <a:p>
+            <a:r>
+              <a:t>Pick 03 if your question at work is "which model should we pay for" — its Azure half needs the room key. 02's done-check: the sparse report comes back with nulls and the validator says PASS/REJECT honestly.</a:t>
+            </a:r>
+          </a:p>
+          <a:p>
+            <a:r>
+              <a:t>Finished everything? Help someone near you.</a:t>
             </a:r>
           </a:p>
         </p:txBody>
@@ -2882,7 +2965,7 @@
             <a:spLocks noGrp="1"/>
           </p:cNvSpPr>
           <p:nvPr>
-            <p:ph type="sldNum" idx="5" sz="quarter"/>
+            <p:ph type="sldNum" sz="quarter" idx="5"/>
           </p:nvPr>
         </p:nvSpPr>
         <p:spPr/>
@@ -2896,7 +2979,7 @@
 </file>
 
 <file path=ppt/notesSlides/notesSlide32.xml><?xml version="1.0" encoding="utf-8"?>
-<p:notes xmlns:a="http://schemas.openxmlformats.org/drawingml/2006/main" xmlns:p="http://schemas.openxmlformats.org/presentationml/2006/main" xmlns:r="http://schemas.openxmlformats.org/officeDocument/2006/relationships">
+<p:notes xmlns:a="http://schemas.openxmlformats.org/drawingml/2006/main" xmlns:r="http://schemas.openxmlformats.org/officeDocument/2006/relationships" xmlns:p="http://schemas.openxmlformats.org/presentationml/2006/main">
   <p:cSld>
     <p:spTree>
       <p:nvGrpSpPr>
@@ -2916,7 +2999,7 @@
         <p:nvSpPr>
           <p:cNvPr id="2" name="Slide Image Placeholder 1"/>
           <p:cNvSpPr>
-            <a:spLocks noGrp="1"/>
+            <a:spLocks noGrp="1" noRot="1" noChangeAspect="1"/>
           </p:cNvSpPr>
           <p:nvPr>
             <p:ph type="sldImg" idx="2"/>
@@ -2931,7 +3014,7 @@
             <a:spLocks noGrp="1"/>
           </p:cNvSpPr>
           <p:nvPr>
-            <p:ph type="body" idx="3" sz="quarter"/>
+            <p:ph type="body" sz="quarter" idx="3"/>
           </p:nvPr>
         </p:nvSpPr>
         <p:spPr/>
@@ -2940,7 +3023,12 @@
           <a:lstStyle/>
           <a:p>
             <a:r>
-              <a:t>The textbook version: sentiment analysis identifies the emotional polarity of a piece of text. The stars lie; the words mostly don't.</a:t>
+              <a:t>Ask two people what surprised them.</a:t>
+            </a:r>
+          </a:p>
+          <a:p>
+            <a:r>
+              <a:t>Prompts if quiet: what surfaced the buried bridge, and what invented one? Rows 1–3 of the framework are done. Break, then Module 2.</a:t>
             </a:r>
           </a:p>
         </p:txBody>
@@ -2952,7 +3040,7 @@
             <a:spLocks noGrp="1"/>
           </p:cNvSpPr>
           <p:nvPr>
-            <p:ph type="sldNum" idx="5" sz="quarter"/>
+            <p:ph type="sldNum" sz="quarter" idx="5"/>
           </p:nvPr>
         </p:nvSpPr>
         <p:spPr/>
@@ -3028,12 +3116,7 @@
           <a:lstStyle/>
           <a:p>
             <a:r>
-              <a:t>One model call + one careful instruction; the rhythm is three demos, then your lab hour.</a:t>
-            </a:r>
-          </a:p>
-          <a:p>
-            <a:r>
-              <a:t>Three features, one shape: a single chat call and a carefully written instruction. No vector database, no training, no cloud.</a:t>
+              <a:t>03: three hundred reviews get a label, and you measure which model deserves the money.</a:t>
             </a:r>
           </a:p>
           <a:p>
@@ -3043,7 +3126,7 @@
           </a:p>
           <a:p>
             <a:r>
-              <a:t>Set the rhythm expectation out loud: three quick demos with a card for your boss after each, then the room builds for an hour — 01 recommended, 02 and 03 for anyone with time left.</a:t>
+              <a:t>Set the rhythm expectation out loud: three quick demos with a card for your boss after each, then the room builds for an hour: 01 recommended, 02 and 03 for anyone with time left.</a:t>
             </a:r>
           </a:p>
         </p:txBody>
@@ -3199,83 +3282,7 @@
           <a:lstStyle/>
           <a:p>
             <a:r>
-              <a:t>A required "hazards" slot with nothing honest to put in it is an invitation to make something up. The invented bear-related closure happens on the clean report; numbers are in </a:t>
-            </a:r>
-            <a:r>
-              <a:rPr>
-                <a:latin typeface="Consolas"/>
-              </a:rPr>
-              <a:t>expected-output.md</a:t>
-            </a:r>
-            <a:r>
-              <a:t>. Point at the Ollama endpoint at the end: there was no API key, and no data left the room.</a:t>
-            </a:r>
-          </a:p>
-          <a:p>
-            <a:r>
-              <a:t>Demo script (~8 min; the reshape in step 6 is the first cut):</a:t>
-            </a:r>
-          </a:p>
-          <a:p>
-            <a:r>
-              <a:t>1. Open a raw trip report from </a:t>
-            </a:r>
-            <a:r>
-              <a:rPr>
-                <a:latin typeface="Consolas"/>
-              </a:rPr>
-              <a:t>data/trip-reports/</a:t>
-            </a:r>
-            <a:r>
-              <a:t> on screen and scroll through it slowly, so the room feels the problem before seeing the fix.</a:t>
-            </a:r>
-          </a:p>
-          <a:p>
-            <a:r>
-              <a:t>2. Starter project: </a:t>
-            </a:r>
-            <a:r>
-              <a:rPr>
-                <a:latin typeface="Consolas"/>
-              </a:rPr>
-              <a:t>IChatClient</a:t>
-            </a:r>
-            <a:r>
-              <a:t> wired to Ollama via Microsoft.Extensions.AI. One method, one prompt: "Summarize this trip report."</a:t>
-            </a:r>
-          </a:p>
-          <a:p>
-            <a:r>
-              <a:t>3. Run it and get a faithful, generic, useless book report, then name the failure out loud: right model, wrong instruction.</a:t>
-            </a:r>
-          </a:p>
-          <a:p>
-            <a:r>
-              <a:t>4. Iterate the prompt live into the hiker-focused version (conditions, hazards, crowding, ignore everything else). Run again. This is the payoff: three bullets, and the bridge warning surfaces.</a:t>
-            </a:r>
-          </a:p>
-          <a:p>
-            <a:r>
-              <a:t>5. Point at the last two lines of that prompt, the grounding lines. Without them, this exact prompt run against the clean report invented a bear-related trail closure in roughly half of runs, because a required "hazards" slot with nothing honest to put in it is an invitation to make something up. The numbers and the failing outputs are in </a:t>
-            </a:r>
-            <a:r>
-              <a:rPr>
-                <a:latin typeface="Consolas"/>
-              </a:rPr>
-              <a:t>expected-output.md</a:t>
-            </a:r>
-            <a:r>
-              <a:t>.</a:t>
-            </a:r>
-          </a:p>
-          <a:p>
-            <a:r>
-              <a:t>6. Change the shape: same call, but output a one-line "trail status" headline for a card UI. Same feature, different product surface.</a:t>
-            </a:r>
-          </a:p>
-          <a:p>
-            <a:r>
-              <a:t>7. Point at the Ollama endpoint in the code. This ran entirely on the laptop, with no API key and no data leaving the room.</a:t>
+              <a:t>The textbook version: automatic summarization produces a shorter text that keeps the key information of the source. Read the slide, let it sit a beat, then the problem.</a:t>
             </a:r>
           </a:p>
         </p:txBody>
@@ -3345,12 +3352,178 @@
           <a:lstStyle/>
           <a:p>
             <a:r>
-              <a:t>Reviews, tickets, reports, meeting notes, threads. One call per document. Row 1 of the framework.</a:t>
-            </a:r>
-          </a:p>
-          <a:p>
-            <a:r>
-              <a:t>If asked about cost: days of work, free local models, no new infrastructure.</a:t>
+              <a:rPr dirty="0"/>
+              <a:t>~8 min · Terminal 2 · </a:t>
+            </a:r>
+            <a:r>
+              <a:rPr dirty="0">
+                <a:latin typeface="Consolas"/>
+              </a:rPr>
+              <a:t>cd modules/M1-understanding/F01-summarization/dotnet</a:t>
+            </a:r>
+          </a:p>
+          <a:p>
+            <a:r>
+              <a:rPr dirty="0"/>
+              <a:t>Files: </a:t>
+            </a:r>
+            <a:r>
+              <a:rPr dirty="0">
+                <a:latin typeface="Consolas"/>
+              </a:rPr>
+              <a:t>tr-0004.md</a:t>
+            </a:r>
+            <a:r>
+              <a:rPr dirty="0"/>
+              <a:t> = the story's report, bridge buried mid-text · </a:t>
+            </a:r>
+            <a:r>
+              <a:rPr dirty="0">
+                <a:latin typeface="Consolas"/>
+              </a:rPr>
+              <a:t>tr-0001.md</a:t>
+            </a:r>
+            <a:r>
+              <a:rPr dirty="0"/>
+              <a:t> = clean report, nothing closed (hallucination bait)</a:t>
+            </a:r>
+          </a:p>
+          <a:p>
+            <a:r>
+              <a:rPr dirty="0"/>
+              <a:t>Flags: none = naive "Summarize this" · </a:t>
+            </a:r>
+            <a:r>
+              <a:rPr dirty="0">
+                <a:latin typeface="Consolas"/>
+              </a:rPr>
+              <a:t>--briefing</a:t>
+            </a:r>
+            <a:r>
+              <a:rPr dirty="0"/>
+              <a:t> = 3 hiker bullets · </a:t>
+            </a:r>
+            <a:r>
+              <a:rPr dirty="0">
+                <a:latin typeface="Consolas"/>
+              </a:rPr>
+              <a:t>--headline</a:t>
+            </a:r>
+            <a:r>
+              <a:rPr dirty="0"/>
+              <a:t> = one-line trail card · </a:t>
+            </a:r>
+            <a:r>
+              <a:rPr dirty="0">
+                <a:latin typeface="Consolas"/>
+              </a:rPr>
+              <a:t>--audience ranger</a:t>
+            </a:r>
+            <a:r>
+              <a:rPr dirty="0"/>
+              <a:t> = same report, different reader</a:t>
+            </a:r>
+          </a:p>
+          <a:p>
+            <a:r>
+              <a:rPr dirty="0"/>
+              <a:t>1. Open </a:t>
+            </a:r>
+            <a:r>
+              <a:rPr dirty="0">
+                <a:latin typeface="Consolas"/>
+              </a:rPr>
+              <a:t>data/tr-0004.md</a:t>
+            </a:r>
+            <a:r>
+              <a:rPr dirty="0"/>
+              <a:t>, scroll. The bridge is one sentence, mid-report.</a:t>
+            </a:r>
+          </a:p>
+          <a:p>
+            <a:r>
+              <a:rPr dirty="0"/>
+              <a:t>2. Before: </a:t>
+            </a:r>
+            <a:r>
+              <a:rPr dirty="0">
+                <a:latin typeface="Consolas"/>
+              </a:rPr>
+              <a:t>cd starter &amp;&amp; dotnet run -- ../../data/tr-0004.md</a:t>
+            </a:r>
+            <a:r>
+              <a:rPr dirty="0"/>
+              <a:t>. Book report. Right model, wrong instruction.</a:t>
+            </a:r>
+          </a:p>
+          <a:p>
+            <a:r>
+              <a:rPr dirty="0"/>
+              <a:t>3. After: </a:t>
+            </a:r>
+            <a:r>
+              <a:rPr dirty="0">
+                <a:latin typeface="Consolas"/>
+              </a:rPr>
+              <a:t>cd ../complete &amp;&amp; dotnet run -- --briefing</a:t>
+            </a:r>
+            <a:r>
+              <a:rPr dirty="0"/>
+              <a:t>. Same report, three bullets, washout leads. Show the prompt.</a:t>
+            </a:r>
+          </a:p>
+          <a:p>
+            <a:r>
+              <a:rPr dirty="0"/>
+              <a:t>4. </a:t>
+            </a:r>
+            <a:r>
+              <a:rPr dirty="0">
+                <a:latin typeface="Consolas"/>
+              </a:rPr>
+              <a:t>dotnet run -- --briefing ../../data/tr-0001.md</a:t>
+            </a:r>
+            <a:r>
+              <a:rPr dirty="0"/>
+              <a:t>: the clean report, nothing closed. Last two prompt lines: 11 of 24 became 1 of 24.</a:t>
+            </a:r>
+          </a:p>
+          <a:p>
+            <a:r>
+              <a:rPr dirty="0"/>
+              <a:t>5. </a:t>
+            </a:r>
+            <a:r>
+              <a:rPr dirty="0">
+                <a:latin typeface="Consolas"/>
+              </a:rPr>
+              <a:t>dotnet run -- --headline</a:t>
+            </a:r>
+            <a:r>
+              <a:rPr dirty="0"/>
+              <a:t>: one line for a card.</a:t>
+            </a:r>
+          </a:p>
+          <a:p>
+            <a:r>
+              <a:rPr dirty="0"/>
+              <a:t>6. Line 11: </a:t>
+            </a:r>
+            <a:r>
+              <a:rPr dirty="0">
+                <a:latin typeface="Consolas"/>
+              </a:rPr>
+              <a:t>localhost:11434</a:t>
+            </a:r>
+            <a:r>
+              <a:rPr dirty="0"/>
+              <a:t>. No key, nothing left the room.</a:t>
+            </a:r>
+          </a:p>
+          <a:p>
+            <a:r>
+              <a:rPr dirty="0"/>
+              <a:t>Cut: 5, then 4.</a:t>
             </a:r>
           </a:p>
         </p:txBody>
@@ -3420,12 +3593,7 @@
           <a:lstStyle/>
           <a:p>
             <a:r>
-              <a:t>Reviews, tickets, reports, meeting notes, threads. One call per document. Row 1 of the framework.</a:t>
-            </a:r>
-          </a:p>
-          <a:p>
-            <a:r>
-              <a:t>If asked about cost: days of work, free local models, no new infrastructure.</a:t>
+              <a:t>Reviews, tickets, reports, meeting notes, threads. One call per document.</a:t>
             </a:r>
           </a:p>
         </p:txBody>
@@ -3495,12 +3663,7 @@
           <a:lstStyle/>
           <a:p>
             <a:r>
-              <a:t>Reviews, tickets, reports, meeting notes, threads. One call per document. Row 1 of the framework.</a:t>
-            </a:r>
-          </a:p>
-          <a:p>
-            <a:r>
-              <a:t>If asked about cost: days of work, free local models, no new infrastructure.</a:t>
+              <a:t>The line for your boss; read it. Row 1 of the framework.</a:t>
             </a:r>
           </a:p>
         </p:txBody>
@@ -3654,7 +3817,7 @@
             <a:fld id="{FDB08721-E45B-4A66-93A6-531BE00DB2CF}" type="datetimeFigureOut">
               <a:rPr lang="en-US" smtClean="0"/>
               <a:pPr defTabSz="342900"/>
-              <a:t>9/1/26</a:t>
+              <a:t>9/3/26</a:t>
             </a:fld>
             <a:endParaRPr lang="en-US"/>
           </a:p>
@@ -3996,7 +4159,7 @@
                 </a:solidFill>
               </a:rPr>
               <a:pPr defTabSz="342900"/>
-              <a:t>9/1/26</a:t>
+              <a:t>9/3/26</a:t>
             </a:fld>
             <a:endParaRPr lang="en-US">
               <a:solidFill>
@@ -4209,7 +4372,7 @@
                 </a:solidFill>
               </a:rPr>
               <a:pPr defTabSz="342900"/>
-              <a:t>9/1/26</a:t>
+              <a:t>9/3/26</a:t>
             </a:fld>
             <a:endParaRPr lang="en-US">
               <a:solidFill>
@@ -4412,7 +4575,7 @@
                 </a:solidFill>
               </a:rPr>
               <a:pPr defTabSz="342900"/>
-              <a:t>9/1/26</a:t>
+              <a:t>9/3/26</a:t>
             </a:fld>
             <a:endParaRPr lang="en-US">
               <a:solidFill>
@@ -4702,7 +4865,7 @@
                 </a:solidFill>
               </a:rPr>
               <a:pPr defTabSz="342900"/>
-              <a:t>9/1/26</a:t>
+              <a:t>9/3/26</a:t>
             </a:fld>
             <a:endParaRPr lang="en-US">
               <a:solidFill>
@@ -5022,7 +5185,7 @@
                 </a:solidFill>
               </a:rPr>
               <a:pPr defTabSz="342900"/>
-              <a:t>9/1/26</a:t>
+              <a:t>9/3/26</a:t>
             </a:fld>
             <a:endParaRPr lang="en-US">
               <a:solidFill>
@@ -5492,7 +5655,7 @@
                 </a:solidFill>
               </a:rPr>
               <a:pPr defTabSz="342900"/>
-              <a:t>9/1/26</a:t>
+              <a:t>9/3/26</a:t>
             </a:fld>
             <a:endParaRPr lang="en-US">
               <a:solidFill>
@@ -5644,7 +5807,7 @@
                 </a:solidFill>
               </a:rPr>
               <a:pPr defTabSz="342900"/>
-              <a:t>9/1/26</a:t>
+              <a:t>9/3/26</a:t>
             </a:fld>
             <a:endParaRPr lang="en-US">
               <a:solidFill>
@@ -5774,7 +5937,7 @@
                 </a:solidFill>
               </a:rPr>
               <a:pPr defTabSz="342900"/>
-              <a:t>9/1/26</a:t>
+              <a:t>9/3/26</a:t>
             </a:fld>
             <a:endParaRPr lang="en-US">
               <a:solidFill>
@@ -6163,7 +6326,7 @@
                 </a:solidFill>
               </a:rPr>
               <a:pPr defTabSz="342900"/>
-              <a:t>9/1/26</a:t>
+              <a:t>9/3/26</a:t>
             </a:fld>
             <a:endParaRPr lang="en-US">
               <a:solidFill>
@@ -6494,7 +6657,7 @@
             <a:fld id="{FDB08721-E45B-4A66-93A6-531BE00DB2CF}" type="datetimeFigureOut">
               <a:rPr lang="en-US" smtClean="0"/>
               <a:pPr defTabSz="342900"/>
-              <a:t>9/1/26</a:t>
+              <a:t>9/3/26</a:t>
             </a:fld>
             <a:endParaRPr lang="en-US"/>
           </a:p>
@@ -6738,7 +6901,7 @@
                 </a:solidFill>
               </a:rPr>
               <a:pPr defTabSz="342900"/>
-              <a:t>9/1/26</a:t>
+              <a:t>9/3/26</a:t>
             </a:fld>
             <a:endParaRPr lang="en-US">
               <a:solidFill>
@@ -7238,7 +7401,9 @@
         </p:nvSpPr>
         <p:spPr/>
         <p:txBody>
-          <a:bodyPr/>
+          <a:bodyPr>
+            <a:normAutofit lnSpcReduction="10000"/>
+          </a:bodyPr>
           <a:lstStyle/>
           <a:p>
             <a:r>
@@ -7429,7 +7594,13 @@
   <p:cSld>
     <p:spTree>
       <p:nvGrpSpPr>
-        <p:cNvPr id="1" name=""/>
+        <p:cNvPr id="1" name="">
+          <a:extLst>
+            <a:ext uri="{FF2B5EF4-FFF2-40B4-BE49-F238E27FC236}">
+              <a16:creationId xmlns:a16="http://schemas.microsoft.com/office/drawing/2014/main" id="{94C4CDB7-CDC5-8161-1D68-1BCE57C5D3B3}"/>
+            </a:ext>
+          </a:extLst>
+        </p:cNvPr>
         <p:cNvGrpSpPr/>
         <p:nvPr/>
       </p:nvGrpSpPr>
@@ -7443,7 +7614,13 @@
       </p:grpSpPr>
       <p:sp>
         <p:nvSpPr>
-          <p:cNvPr id="2" name="Title 1"/>
+          <p:cNvPr id="2" name="Title 1">
+            <a:extLst>
+              <a:ext uri="{FF2B5EF4-FFF2-40B4-BE49-F238E27FC236}">
+                <a16:creationId xmlns:a16="http://schemas.microsoft.com/office/drawing/2014/main" id="{D6205BD6-CF58-50B1-1C59-69EB2C3DCF1C}"/>
+              </a:ext>
+            </a:extLst>
+          </p:cNvPr>
           <p:cNvSpPr>
             <a:spLocks noGrp="1"/>
           </p:cNvSpPr>
@@ -7464,7 +7641,13 @@
       </p:sp>
       <p:sp>
         <p:nvSpPr>
-          <p:cNvPr id="3" name="Content Placeholder 2"/>
+          <p:cNvPr id="3" name="Content Placeholder 2">
+            <a:extLst>
+              <a:ext uri="{FF2B5EF4-FFF2-40B4-BE49-F238E27FC236}">
+                <a16:creationId xmlns:a16="http://schemas.microsoft.com/office/drawing/2014/main" id="{53AA7B6A-70F0-B6ED-7F8B-CFDD9B0C5D16}"/>
+              </a:ext>
+            </a:extLst>
+          </p:cNvPr>
           <p:cNvSpPr>
             <a:spLocks noGrp="1"/>
           </p:cNvSpPr>
@@ -7510,6 +7693,7 @@
               <a:rPr sz="2800" dirty="0"/>
               <a:t> "Our users are drowning in text we already have. A few hours of work turns it into automatic answers."</a:t>
             </a:r>
+            <a:endParaRPr lang="en-US" sz="2800" dirty="0"/>
           </a:p>
           <a:p>
             <a:pPr>
@@ -7517,20 +7701,31 @@
                 <a:spcPts val="1400"/>
               </a:spcAft>
             </a:pPr>
-            <a:r>
-              <a:rPr sz="2800" b="1" dirty="0"/>
+            <a:endParaRPr lang="en-US" sz="2800" dirty="0"/>
+          </a:p>
+          <a:p>
+            <a:pPr>
+              <a:spcAft>
+                <a:spcPts val="1400"/>
+              </a:spcAft>
+            </a:pPr>
+            <a:r>
+              <a:rPr lang="en-US" sz="2800" b="1" dirty="0"/>
               <a:t>Difficulty:</a:t>
             </a:r>
-            <a:r>
-              <a:rPr sz="2800" dirty="0"/>
-              <a:t> </a:t>
-            </a:r>
-          </a:p>
-        </p:txBody>
-      </p:sp>
-      <p:sp>
-        <p:nvSpPr>
-          <p:cNvPr id="4" name="Rounded Rectangle 3"/>
+            <a:endParaRPr sz="2800" dirty="0"/>
+          </a:p>
+        </p:txBody>
+      </p:sp>
+      <p:sp>
+        <p:nvSpPr>
+          <p:cNvPr id="4" name="Rounded Rectangle 3">
+            <a:extLst>
+              <a:ext uri="{FF2B5EF4-FFF2-40B4-BE49-F238E27FC236}">
+                <a16:creationId xmlns:a16="http://schemas.microsoft.com/office/drawing/2014/main" id="{B1E8BDC2-EDF4-3F70-F39F-5D43BC13C20A}"/>
+              </a:ext>
+            </a:extLst>
+          </p:cNvPr>
           <p:cNvSpPr/>
           <p:nvPr/>
         </p:nvSpPr>
@@ -7577,7 +7772,13 @@
       </p:sp>
       <p:sp>
         <p:nvSpPr>
-          <p:cNvPr id="5" name="Rounded Rectangle 4"/>
+          <p:cNvPr id="5" name="Rounded Rectangle 4">
+            <a:extLst>
+              <a:ext uri="{FF2B5EF4-FFF2-40B4-BE49-F238E27FC236}">
+                <a16:creationId xmlns:a16="http://schemas.microsoft.com/office/drawing/2014/main" id="{CAF20ED4-4633-3742-5916-E3B2624E2928}"/>
+              </a:ext>
+            </a:extLst>
+          </p:cNvPr>
           <p:cNvSpPr/>
           <p:nvPr/>
         </p:nvSpPr>
@@ -7624,7 +7825,13 @@
       </p:sp>
       <p:sp>
         <p:nvSpPr>
-          <p:cNvPr id="6" name="Rounded Rectangle 5"/>
+          <p:cNvPr id="6" name="Rounded Rectangle 5">
+            <a:extLst>
+              <a:ext uri="{FF2B5EF4-FFF2-40B4-BE49-F238E27FC236}">
+                <a16:creationId xmlns:a16="http://schemas.microsoft.com/office/drawing/2014/main" id="{1D0D4B1B-DE8A-C911-7CFB-36A2E19A9B00}"/>
+              </a:ext>
+            </a:extLst>
+          </p:cNvPr>
           <p:cNvSpPr/>
           <p:nvPr/>
         </p:nvSpPr>
@@ -7671,7 +7878,13 @@
       </p:sp>
       <p:sp>
         <p:nvSpPr>
-          <p:cNvPr id="7" name="TextBox 6"/>
+          <p:cNvPr id="7" name="TextBox 6">
+            <a:extLst>
+              <a:ext uri="{FF2B5EF4-FFF2-40B4-BE49-F238E27FC236}">
+                <a16:creationId xmlns:a16="http://schemas.microsoft.com/office/drawing/2014/main" id="{4BA60149-5DC8-C3A6-7EF7-64310D95CDE3}"/>
+              </a:ext>
+            </a:extLst>
+          </p:cNvPr>
           <p:cNvSpPr txBox="1"/>
           <p:nvPr/>
         </p:nvSpPr>
@@ -7700,6 +7913,11 @@
         </p:txBody>
       </p:sp>
     </p:spTree>
+    <p:extLst>
+      <p:ext uri="{BB962C8B-B14F-4D97-AF65-F5344CB8AC3E}">
+        <p14:creationId xmlns:p14="http://schemas.microsoft.com/office/powerpoint/2010/main" val="4155427989"/>
+      </p:ext>
+    </p:extLst>
   </p:cSld>
   <p:clrMapOvr>
     <a:masterClrMapping/>
@@ -7762,7 +7980,9 @@
         </p:nvSpPr>
         <p:spPr/>
         <p:txBody>
-          <a:bodyPr/>
+          <a:bodyPr>
+            <a:normAutofit lnSpcReduction="10000"/>
+          </a:bodyPr>
           <a:lstStyle/>
           <a:p>
             <a:endParaRPr/>
@@ -7802,7 +8022,7 @@
 </file>
 
 <file path=ppt/slides/slide13.xml><?xml version="1.0" encoding="utf-8"?>
-<p:sld xmlns:a="http://schemas.openxmlformats.org/drawingml/2006/main" xmlns:p="http://schemas.openxmlformats.org/presentationml/2006/main" xmlns:r="http://schemas.openxmlformats.org/officeDocument/2006/relationships">
+<p:sld xmlns:a="http://schemas.openxmlformats.org/drawingml/2006/main" xmlns:r="http://schemas.openxmlformats.org/officeDocument/2006/relationships" xmlns:p="http://schemas.openxmlformats.org/presentationml/2006/main">
   <p:cSld>
     <p:spTree>
       <p:nvGrpSpPr>
@@ -7810,7 +8030,14 @@
         <p:cNvGrpSpPr/>
         <p:nvPr/>
       </p:nvGrpSpPr>
-      <p:grpSpPr/>
+      <p:grpSpPr>
+        <a:xfrm>
+          <a:off x="0" y="0"/>
+          <a:ext cx="0" cy="0"/>
+          <a:chOff x="0" y="0"/>
+          <a:chExt cx="0" cy="0"/>
+        </a:xfrm>
+      </p:grpSpPr>
       <p:pic>
         <p:nvPicPr>
           <p:cNvPr id="2" name="Picture 1" descr="image.png"/>
@@ -7820,7 +8047,7 @@
           <p:nvPr/>
         </p:nvPicPr>
         <p:blipFill>
-          <a:blip r:embed="rId2"/>
+          <a:blip r:embed="rId3"/>
           <a:stretch>
             <a:fillRect/>
           </a:stretch>
@@ -7843,8 +8070,8 @@
         </p:nvSpPr>
         <p:spPr>
           <a:xfrm>
-            <a:off x="914400" y="2834640"/>
-            <a:ext cx="10332720" cy="2011680"/>
+            <a:off x="914400" y="3178760"/>
+            <a:ext cx="10332720" cy="1323439"/>
           </a:xfrm>
           <a:prstGeom prst="rect">
             <a:avLst/>
@@ -7859,11 +8086,19 @@
           <a:p>
             <a:pPr algn="ctr"/>
             <a:r>
-              <a:rPr sz="4000"/>
-              <a:t>Pull facts out of free-form text into </a:t>
-            </a:r>
-            <a:r>
-              <a:rPr b="1" sz="4000">
+              <a:rPr sz="4000" dirty="0"/>
+              <a:t>Pull facts out of free-form text </a:t>
+            </a:r>
+            <a:endParaRPr lang="en-US" sz="4000" dirty="0"/>
+          </a:p>
+          <a:p>
+            <a:pPr algn="ctr"/>
+            <a:r>
+              <a:rPr sz="4000" dirty="0"/>
+              <a:t>into </a:t>
+            </a:r>
+            <a:r>
+              <a:rPr sz="4000" b="1" dirty="0">
                 <a:solidFill>
                   <a:srgbClr val="017AB4"/>
                 </a:solidFill>
@@ -7871,7 +8106,7 @@
               <a:t>fields your code can query</a:t>
             </a:r>
             <a:r>
-              <a:rPr sz="4000"/>
+              <a:rPr sz="4000" dirty="0"/>
               <a:t>.</a:t>
             </a:r>
           </a:p>
@@ -7886,7 +8121,7 @@
           <p:nvPr/>
         </p:nvPicPr>
         <p:blipFill>
-          <a:blip r:embed="rId3"/>
+          <a:blip r:embed="rId4"/>
           <a:stretch>
             <a:fillRect/>
           </a:stretch>
@@ -11367,35 +11602,41 @@
           <a:lstStyle/>
           <a:p>
             <a:r>
-              <a:rPr sz="2800"/>
+              <a:rPr sz="2800" dirty="0"/>
               <a:t>A C# record (</a:t>
             </a:r>
             <a:r>
-              <a:rPr sz="2800">
+              <a:rPr sz="2800" dirty="0" err="1">
                 <a:latin typeface="Consolas"/>
               </a:rPr>
               <a:t>TripFacts</a:t>
             </a:r>
             <a:r>
-              <a:rPr sz="2800"/>
+              <a:rPr sz="2800" dirty="0"/>
               <a:t>) · typed response · no parsing</a:t>
             </a:r>
           </a:p>
           <a:p>
             <a:r>
-              <a:rPr sz="2800"/>
+              <a:rPr sz="2800" dirty="0"/>
               <a:t>❌ No distance in the report → </a:t>
             </a:r>
             <a:r>
-              <a:rPr sz="2800">
+              <a:rPr sz="2800" dirty="0" err="1">
                 <a:latin typeface="Consolas"/>
               </a:rPr>
-              <a:t>distance_mi: 5.0</a:t>
-            </a:r>
-          </a:p>
-          <a:p>
-            <a:r>
-              <a:rPr sz="2800"/>
+              <a:t>distance_mi</a:t>
+            </a:r>
+            <a:r>
+              <a:rPr sz="2800" dirty="0">
+                <a:latin typeface="Consolas"/>
+              </a:rPr>
+              <a:t>: 5.0</a:t>
+            </a:r>
+          </a:p>
+          <a:p>
+            <a:r>
+              <a:rPr sz="2800" dirty="0"/>
               <a:t>✅ Nullable fields + "null when not stated"</a:t>
             </a:r>
           </a:p>
@@ -11407,7 +11648,7 @@
           </a:p>
           <a:p>
             <a:r>
-              <a:rPr sz="2800"/>
+              <a:rPr sz="2800" dirty="0"/>
               <a:t>The last mile is a validator — ordinary code</a:t>
             </a:r>
           </a:p>
@@ -11975,7 +12216,9 @@
         </p:nvSpPr>
         <p:spPr/>
         <p:txBody>
-          <a:bodyPr/>
+          <a:bodyPr>
+            <a:normAutofit lnSpcReduction="10000"/>
+          </a:bodyPr>
           <a:lstStyle/>
           <a:p>
             <a:endParaRPr/>
@@ -12015,7 +12258,7 @@
 </file>
 
 <file path=ppt/slides/slide28.xml><?xml version="1.0" encoding="utf-8"?>
-<p:sld xmlns:a="http://schemas.openxmlformats.org/drawingml/2006/main" xmlns:p="http://schemas.openxmlformats.org/presentationml/2006/main" xmlns:r="http://schemas.openxmlformats.org/officeDocument/2006/relationships">
+<p:sld xmlns:a="http://schemas.openxmlformats.org/drawingml/2006/main" xmlns:r="http://schemas.openxmlformats.org/officeDocument/2006/relationships" xmlns:p="http://schemas.openxmlformats.org/presentationml/2006/main">
   <p:cSld>
     <p:spTree>
       <p:nvGrpSpPr>
@@ -12023,7 +12266,14 @@
         <p:cNvGrpSpPr/>
         <p:nvPr/>
       </p:nvGrpSpPr>
-      <p:grpSpPr/>
+      <p:grpSpPr>
+        <a:xfrm>
+          <a:off x="0" y="0"/>
+          <a:ext cx="0" cy="0"/>
+          <a:chOff x="0" y="0"/>
+          <a:chExt cx="0" cy="0"/>
+        </a:xfrm>
+      </p:grpSpPr>
       <p:pic>
         <p:nvPicPr>
           <p:cNvPr id="2" name="Picture 1" descr="image.png"/>
@@ -12033,7 +12283,7 @@
           <p:nvPr/>
         </p:nvPicPr>
         <p:blipFill>
-          <a:blip r:embed="rId2"/>
+          <a:blip r:embed="rId3"/>
           <a:stretch>
             <a:fillRect/>
           </a:stretch>
@@ -12076,7 +12326,7 @@
               <a:t>Read text and judge </a:t>
             </a:r>
             <a:r>
-              <a:rPr b="1" sz="4000">
+              <a:rPr sz="4000" b="1">
                 <a:solidFill>
                   <a:srgbClr val="017AB4"/>
                 </a:solidFill>
@@ -12099,7 +12349,7 @@
           <p:nvPr/>
         </p:nvPicPr>
         <p:blipFill>
-          <a:blip r:embed="rId3"/>
+          <a:blip r:embed="rId4"/>
           <a:stretch>
             <a:fillRect/>
           </a:stretch>
@@ -13690,7 +13940,9 @@
         </p:nvSpPr>
         <p:spPr/>
         <p:txBody>
-          <a:bodyPr/>
+          <a:bodyPr>
+            <a:normAutofit lnSpcReduction="10000"/>
+          </a:bodyPr>
           <a:lstStyle/>
           <a:p>
             <a:endParaRPr/>
@@ -13730,7 +13982,7 @@
 </file>
 
 <file path=ppt/slides/slide6.xml><?xml version="1.0" encoding="utf-8"?>
-<p:sld xmlns:a="http://schemas.openxmlformats.org/drawingml/2006/main" xmlns:p="http://schemas.openxmlformats.org/presentationml/2006/main" xmlns:r="http://schemas.openxmlformats.org/officeDocument/2006/relationships">
+<p:sld xmlns:a="http://schemas.openxmlformats.org/drawingml/2006/main" xmlns:r="http://schemas.openxmlformats.org/officeDocument/2006/relationships" xmlns:p="http://schemas.openxmlformats.org/presentationml/2006/main">
   <p:cSld>
     <p:spTree>
       <p:nvGrpSpPr>
@@ -13738,7 +13990,14 @@
         <p:cNvGrpSpPr/>
         <p:nvPr/>
       </p:nvGrpSpPr>
-      <p:grpSpPr/>
+      <p:grpSpPr>
+        <a:xfrm>
+          <a:off x="0" y="0"/>
+          <a:ext cx="0" cy="0"/>
+          <a:chOff x="0" y="0"/>
+          <a:chExt cx="0" cy="0"/>
+        </a:xfrm>
+      </p:grpSpPr>
       <p:pic>
         <p:nvPicPr>
           <p:cNvPr id="2" name="Picture 1" descr="image.png"/>
@@ -13748,7 +14007,7 @@
           <p:nvPr/>
         </p:nvPicPr>
         <p:blipFill>
-          <a:blip r:embed="rId2"/>
+          <a:blip r:embed="rId3"/>
           <a:stretch>
             <a:fillRect/>
           </a:stretch>
@@ -13771,8 +14030,8 @@
         </p:nvSpPr>
         <p:spPr>
           <a:xfrm>
-            <a:off x="914400" y="2834640"/>
-            <a:ext cx="10332720" cy="2011680"/>
+            <a:off x="914400" y="3178760"/>
+            <a:ext cx="10332720" cy="1323439"/>
           </a:xfrm>
           <a:prstGeom prst="rect">
             <a:avLst/>
@@ -13787,11 +14046,14 @@
           <a:p>
             <a:pPr algn="ctr"/>
             <a:r>
-              <a:rPr sz="4000"/>
+              <a:rPr sz="4000" dirty="0"/>
               <a:t>Turn a long document into the </a:t>
             </a:r>
-            <a:r>
-              <a:rPr b="1" sz="4000">
+            <a:br>
+              <a:rPr lang="en-US" sz="4000" dirty="0"/>
+            </a:br>
+            <a:r>
+              <a:rPr sz="4000" b="1" dirty="0">
                 <a:solidFill>
                   <a:srgbClr val="017AB4"/>
                 </a:solidFill>
@@ -13799,7 +14061,7 @@
               <a:t>short version</a:t>
             </a:r>
             <a:r>
-              <a:rPr sz="4000"/>
+              <a:rPr sz="4000" dirty="0"/>
               <a:t> its reader needs.</a:t>
             </a:r>
           </a:p>
@@ -13814,7 +14076,7 @@
           <p:nvPr/>
         </p:nvPicPr>
         <p:blipFill>
-          <a:blip r:embed="rId3"/>
+          <a:blip r:embed="rId4"/>
           <a:stretch>
             <a:fillRect/>
           </a:stretch>
@@ -14032,31 +14294,31 @@
           <a:lstStyle/>
           <a:p>
             <a:r>
-              <a:rPr sz="2800"/>
+              <a:rPr sz="2800" dirty="0"/>
               <a:t>The raw report first</a:t>
             </a:r>
           </a:p>
           <a:p>
             <a:r>
-              <a:rPr sz="2800"/>
+              <a:rPr sz="2800" dirty="0"/>
               <a:t>❌ Naive prompt: faithful, generic, useless</a:t>
             </a:r>
           </a:p>
           <a:p>
             <a:r>
-              <a:rPr sz="2800"/>
+              <a:rPr sz="2800" dirty="0"/>
               <a:t>✅ Purpose-built prompt: the bridge surfaces</a:t>
             </a:r>
           </a:p>
           <a:p>
             <a:r>
-              <a:rPr sz="2800"/>
+              <a:rPr sz="2800" dirty="0"/>
               <a:t>Grounding lines — without them, ~half of runs invent a closure</a:t>
             </a:r>
           </a:p>
           <a:p>
             <a:r>
-              <a:rPr sz="2800"/>
+              <a:rPr sz="2800" dirty="0"/>
               <a:t>Same call, new shape: a one-line trail status</a:t>
             </a:r>
           </a:p>

</xml_diff>

<commit_message>
Prescriptive lab steps with verbatim prompts; flatten F01 trip reports; drop terminal split from notes
- All ten FNN-lab.md: goal/input/how/model header, one step per action
  naming its file or id, prompts and schemas quoted byte-for-byte from the
  http files, two-sentence checks, no run-count trivia
- F01 data/: the 40 trip reports live directly in data/, the two loose
  duplicates are gone; every reference updated
- F05 azure.http header describes its prompt honestly; F07 lab says what
  the full inbox is for
- Runsheet and demo notes: Azure variables come from ~/.zshrc now, no
  Terminal 1/2 split; F10 runs prefixed with the gpt-5.5 deployment

Co-Authored-By: Claude Fable 5.1 <noreply@anthropic.com>
</commit_message>
<xml_diff>
--- a/docs/slides/pptx/M1-understanding.pptx
+++ b/docs/slides/pptx/M1-understanding.pptx
@@ -1885,11 +1885,10 @@
           <a:lstStyle/>
           <a:p>
             <a:r>
-              <a:rPr dirty="0"/>
-              <a:t>~10 min · Terminal 2 · </a:t>
-            </a:r>
-            <a:r>
-              <a:rPr dirty="0">
+              <a:t>~10 min · </a:t>
+            </a:r>
+            <a:r>
+              <a:rPr>
                 <a:latin typeface="Consolas"/>
               </a:rPr>
               <a:t>cd modules/M1-understanding/F02-extraction/dotnet</a:t>
@@ -1897,121 +1896,95 @@
           </a:p>
           <a:p>
             <a:r>
-              <a:rPr dirty="0"/>
               <a:t>Files: </a:t>
             </a:r>
             <a:r>
-              <a:rPr dirty="0">
+              <a:rPr>
                 <a:latin typeface="Consolas"/>
               </a:rPr>
               <a:t>tr-0007.md</a:t>
             </a:r>
             <a:r>
-              <a:rPr dirty="0"/>
               <a:t> = full report, every field present · </a:t>
             </a:r>
             <a:r>
-              <a:rPr dirty="0">
+              <a:rPr>
                 <a:latin typeface="Consolas"/>
               </a:rPr>
               <a:t>tr-0011.md</a:t>
             </a:r>
             <a:r>
-              <a:rPr dirty="0"/>
               <a:t> = sparse report, no distance stated (the null test)</a:t>
             </a:r>
           </a:p>
           <a:p>
             <a:r>
-              <a:rPr dirty="0" err="1"/>
-              <a:t>Args</a:t>
-            </a:r>
-            <a:r>
-              <a:rPr dirty="0"/>
-              <a:t>: a report path; complete with no </a:t>
-            </a:r>
-            <a:r>
-              <a:rPr dirty="0" err="1"/>
-              <a:t>args</a:t>
-            </a:r>
-            <a:r>
-              <a:rPr dirty="0"/>
-              <a:t> runs both</a:t>
-            </a:r>
-          </a:p>
-          <a:p>
-            <a:r>
-              <a:rPr dirty="0"/>
+              <a:t>Args: a report path; complete with no args runs both</a:t>
+            </a:r>
+          </a:p>
+          <a:p>
+            <a:r>
               <a:t>1. Same kind of report as 01. This time the goal is a database row.</a:t>
             </a:r>
           </a:p>
           <a:p>
             <a:r>
-              <a:rPr dirty="0"/>
               <a:t>2. Before: </a:t>
             </a:r>
             <a:r>
-              <a:rPr dirty="0">
+              <a:rPr>
                 <a:latin typeface="Consolas"/>
               </a:rPr>
               <a:t>cd starter &amp;&amp; dotnet run -- ../../data/tr-0007.md</a:t>
             </a:r>
             <a:r>
-              <a:rPr dirty="0"/>
               <a:t>. JSON asked for in the prompt. Fences, preamble, drifting field names.</a:t>
             </a:r>
           </a:p>
           <a:p>
             <a:r>
-              <a:rPr dirty="0"/>
               <a:t>3. After: </a:t>
             </a:r>
             <a:r>
-              <a:rPr dirty="0">
+              <a:rPr>
                 <a:latin typeface="Consolas"/>
               </a:rPr>
               <a:t>cd ../complete &amp;&amp; dotnet run -- ../../data/tr-0007.md</a:t>
             </a:r>
             <a:r>
-              <a:rPr dirty="0"/>
               <a:t>. </a:t>
             </a:r>
             <a:r>
-              <a:rPr dirty="0" err="1">
+              <a:rPr>
                 <a:latin typeface="Consolas"/>
               </a:rPr>
               <a:t>TripFacts</a:t>
             </a:r>
             <a:r>
-              <a:rPr dirty="0"/>
               <a:t> record, typed response, no parsing.</a:t>
             </a:r>
           </a:p>
           <a:p>
             <a:r>
-              <a:rPr dirty="0"/>
               <a:t>4. </a:t>
             </a:r>
             <a:r>
-              <a:rPr dirty="0">
+              <a:rPr>
                 <a:latin typeface="Consolas"/>
               </a:rPr>
               <a:t>dotnet run -- ../../data/tr-0011.md</a:t>
             </a:r>
             <a:r>
-              <a:rPr dirty="0"/>
               <a:t>, three times. Nulls where there is nothing, and watch what still slips.</a:t>
             </a:r>
           </a:p>
           <a:p>
             <a:r>
-              <a:rPr dirty="0"/>
               <a:t>5. Point at the validator: PASS or REJECT. A rejected record is a good outcome.</a:t>
             </a:r>
           </a:p>
           <a:p>
             <a:r>
-              <a:rPr dirty="0"/>
               <a:t>Cut: 4's repeats.</a:t>
             </a:r>
           </a:p>
@@ -2437,7 +2410,7 @@
           <a:lstStyle/>
           <a:p>
             <a:r>
-              <a:t>~10 min · Terminal 1 (Azure) · </a:t>
+              <a:t>~10 min · </a:t>
             </a:r>
             <a:r>
               <a:rPr>
@@ -3352,11 +3325,10 @@
           <a:lstStyle/>
           <a:p>
             <a:r>
-              <a:rPr dirty="0"/>
-              <a:t>~8 min · Terminal 2 · </a:t>
-            </a:r>
-            <a:r>
-              <a:rPr dirty="0">
+              <a:t>~8 min · </a:t>
+            </a:r>
+            <a:r>
+              <a:rPr>
                 <a:latin typeface="Consolas"/>
               </a:rPr>
               <a:t>cd modules/M1-understanding/F01-summarization/dotnet</a:t>
@@ -3364,165 +3336,145 @@
           </a:p>
           <a:p>
             <a:r>
-              <a:rPr dirty="0"/>
               <a:t>Files: </a:t>
             </a:r>
             <a:r>
-              <a:rPr dirty="0">
+              <a:rPr>
                 <a:latin typeface="Consolas"/>
               </a:rPr>
               <a:t>tr-0004.md</a:t>
             </a:r>
             <a:r>
-              <a:rPr dirty="0"/>
               <a:t> = the story's report, bridge buried mid-text · </a:t>
             </a:r>
             <a:r>
-              <a:rPr dirty="0">
+              <a:rPr>
                 <a:latin typeface="Consolas"/>
               </a:rPr>
               <a:t>tr-0001.md</a:t>
             </a:r>
             <a:r>
-              <a:rPr dirty="0"/>
               <a:t> = clean report, nothing closed (hallucination bait)</a:t>
             </a:r>
           </a:p>
           <a:p>
             <a:r>
-              <a:rPr dirty="0"/>
               <a:t>Flags: none = naive "Summarize this" · </a:t>
             </a:r>
             <a:r>
-              <a:rPr dirty="0">
+              <a:rPr>
                 <a:latin typeface="Consolas"/>
               </a:rPr>
               <a:t>--briefing</a:t>
             </a:r>
             <a:r>
-              <a:rPr dirty="0"/>
               <a:t> = 3 hiker bullets · </a:t>
             </a:r>
             <a:r>
-              <a:rPr dirty="0">
+              <a:rPr>
                 <a:latin typeface="Consolas"/>
               </a:rPr>
               <a:t>--headline</a:t>
             </a:r>
             <a:r>
-              <a:rPr dirty="0"/>
               <a:t> = one-line trail card · </a:t>
             </a:r>
             <a:r>
-              <a:rPr dirty="0">
+              <a:rPr>
                 <a:latin typeface="Consolas"/>
               </a:rPr>
               <a:t>--audience ranger</a:t>
             </a:r>
             <a:r>
-              <a:rPr dirty="0"/>
               <a:t> = same report, different reader</a:t>
             </a:r>
           </a:p>
           <a:p>
             <a:r>
-              <a:rPr dirty="0"/>
               <a:t>1. Open </a:t>
             </a:r>
             <a:r>
-              <a:rPr dirty="0">
+              <a:rPr>
                 <a:latin typeface="Consolas"/>
               </a:rPr>
               <a:t>data/tr-0004.md</a:t>
             </a:r>
             <a:r>
-              <a:rPr dirty="0"/>
               <a:t>, scroll. The bridge is one sentence, mid-report.</a:t>
             </a:r>
           </a:p>
           <a:p>
             <a:r>
-              <a:rPr dirty="0"/>
               <a:t>2. Before: </a:t>
             </a:r>
             <a:r>
-              <a:rPr dirty="0">
+              <a:rPr>
                 <a:latin typeface="Consolas"/>
               </a:rPr>
               <a:t>cd starter &amp;&amp; dotnet run -- ../../data/tr-0004.md</a:t>
             </a:r>
             <a:r>
-              <a:rPr dirty="0"/>
               <a:t>. Book report. Right model, wrong instruction.</a:t>
             </a:r>
           </a:p>
           <a:p>
             <a:r>
-              <a:rPr dirty="0"/>
               <a:t>3. After: </a:t>
             </a:r>
             <a:r>
-              <a:rPr dirty="0">
+              <a:rPr>
                 <a:latin typeface="Consolas"/>
               </a:rPr>
               <a:t>cd ../complete &amp;&amp; dotnet run -- --briefing</a:t>
             </a:r>
             <a:r>
-              <a:rPr dirty="0"/>
               <a:t>. Same report, three bullets, washout leads. Show the prompt.</a:t>
             </a:r>
           </a:p>
           <a:p>
             <a:r>
-              <a:rPr dirty="0"/>
               <a:t>4. </a:t>
             </a:r>
             <a:r>
-              <a:rPr dirty="0">
+              <a:rPr>
                 <a:latin typeface="Consolas"/>
               </a:rPr>
               <a:t>dotnet run -- --briefing ../../data/tr-0001.md</a:t>
             </a:r>
             <a:r>
-              <a:rPr dirty="0"/>
               <a:t>: the clean report, nothing closed. Last two prompt lines: 11 of 24 became 1 of 24.</a:t>
             </a:r>
           </a:p>
           <a:p>
             <a:r>
-              <a:rPr dirty="0"/>
               <a:t>5. </a:t>
             </a:r>
             <a:r>
-              <a:rPr dirty="0">
+              <a:rPr>
                 <a:latin typeface="Consolas"/>
               </a:rPr>
               <a:t>dotnet run -- --headline</a:t>
             </a:r>
             <a:r>
-              <a:rPr dirty="0"/>
               <a:t>: one line for a card.</a:t>
             </a:r>
           </a:p>
           <a:p>
             <a:r>
-              <a:rPr dirty="0"/>
               <a:t>6. Line 11: </a:t>
             </a:r>
             <a:r>
-              <a:rPr dirty="0">
+              <a:rPr>
                 <a:latin typeface="Consolas"/>
               </a:rPr>
               <a:t>localhost:11434</a:t>
             </a:r>
             <a:r>
-              <a:rPr dirty="0"/>
               <a:t>. No key, nothing left the room.</a:t>
             </a:r>
           </a:p>
           <a:p>
             <a:r>
-              <a:rPr dirty="0"/>
               <a:t>Cut: 5, then 4.</a:t>
             </a:r>
           </a:p>

</xml_diff>